<commit_message>
ATG storyboard: use the storyboard format, not the CONOPS headings
Text column now reads Purpose, Delivery and Effect, Participant
Feedback, as the NZALC boards do; the worked example carries the ELDA
Lead Systems content in that form.

Co-Authored-By: Claude Fable 5.1 <noreply@anthropic.com>
Claude-Session: https://claude.ai/code/session_01LgFPs3fMSncBgbYQ3PfA3o
</commit_message>
<xml_diff>
--- a/output/atg-storyboard-template.pptx
+++ b/output/atg-storyboard-template.pptx
@@ -1144,7 +1144,7 @@
                 <a:ea typeface="Arial" pitchFamily="34" charset="-122"/>
                 <a:cs typeface="Arial" pitchFamily="34" charset="-120"/>
               </a:rPr>
-              <a:t>INTRODUCTION</a:t>
+              <a:t>PURPOSE</a:t>
             </a:r>
             <a:endParaRPr lang="en-US" sz="700" dirty="0"/>
           </a:p>
@@ -1161,7 +1161,7 @@
         <p:spPr>
           <a:xfrm>
             <a:off x="320040" y="1353312"/>
-            <a:ext cx="3246120" cy="530352"/>
+            <a:ext cx="3246120" cy="640080"/>
           </a:xfrm>
           <a:prstGeom prst="rect">
             <a:avLst/>
@@ -1205,7 +1205,7 @@
                 <a:ea typeface="Arial" pitchFamily="34" charset="-122"/>
                 <a:cs typeface="Arial" pitchFamily="34" charset="-120"/>
               </a:rPr>
-              <a:t>Introduction text</a:t>
+              <a:t>Why the activity was conducted.</a:t>
             </a:r>
             <a:endParaRPr lang="en-US" sz="850" dirty="0"/>
           </a:p>
@@ -1219,7 +1219,7 @@
         </p:nvSpPr>
         <p:spPr>
           <a:xfrm>
-            <a:off x="320040" y="1975104"/>
+            <a:off x="320040" y="2084832"/>
             <a:ext cx="228600" cy="155448"/>
           </a:xfrm>
           <a:prstGeom prst="rect">
@@ -1258,7 +1258,7 @@
         </p:nvSpPr>
         <p:spPr>
           <a:xfrm>
-            <a:off x="548640" y="1975104"/>
+            <a:off x="548640" y="2084832"/>
             <a:ext cx="3017520" cy="155448"/>
           </a:xfrm>
           <a:prstGeom prst="rect">
@@ -1283,7 +1283,7 @@
                 <a:ea typeface="Arial" pitchFamily="34" charset="-122"/>
                 <a:cs typeface="Arial" pitchFamily="34" charset="-120"/>
               </a:rPr>
-              <a:t>PURPOSE</a:t>
+              <a:t>DELIVERY AND EFFECT</a:t>
             </a:r>
             <a:endParaRPr lang="en-US" sz="700" dirty="0"/>
           </a:p>
@@ -1299,8 +1299,8 @@
         </p:nvSpPr>
         <p:spPr>
           <a:xfrm>
-            <a:off x="320040" y="2139696"/>
-            <a:ext cx="3246120" cy="566928"/>
+            <a:off x="320040" y="2249424"/>
+            <a:ext cx="3246120" cy="1572768"/>
           </a:xfrm>
           <a:prstGeom prst="rect">
             <a:avLst/>
@@ -1344,7 +1344,7 @@
                 <a:ea typeface="Arial" pitchFamily="34" charset="-122"/>
                 <a:cs typeface="Arial" pitchFamily="34" charset="-120"/>
               </a:rPr>
-              <a:t>Purpose text</a:t>
+              <a:t>What was delivered, and the effect it had: three or four short points.</a:t>
             </a:r>
             <a:endParaRPr lang="en-US" sz="850" dirty="0"/>
           </a:p>
@@ -1358,7 +1358,7 @@
         </p:nvSpPr>
         <p:spPr>
           <a:xfrm>
-            <a:off x="320040" y="2798064"/>
+            <a:off x="320040" y="3913632"/>
             <a:ext cx="228600" cy="155448"/>
           </a:xfrm>
           <a:prstGeom prst="rect">
@@ -1397,7 +1397,7 @@
         </p:nvSpPr>
         <p:spPr>
           <a:xfrm>
-            <a:off x="548640" y="2798064"/>
+            <a:off x="548640" y="3913632"/>
             <a:ext cx="3017520" cy="155448"/>
           </a:xfrm>
           <a:prstGeom prst="rect">
@@ -1422,7 +1422,7 @@
                 <a:ea typeface="Arial" pitchFamily="34" charset="-122"/>
                 <a:cs typeface="Arial" pitchFamily="34" charset="-120"/>
               </a:rPr>
-              <a:t>METHOD</a:t>
+              <a:t>PARTICIPANT FEEDBACK</a:t>
             </a:r>
             <a:endParaRPr lang="en-US" sz="700" dirty="0"/>
           </a:p>
@@ -1438,8 +1438,8 @@
         </p:nvSpPr>
         <p:spPr>
           <a:xfrm>
-            <a:off x="320040" y="2962656"/>
-            <a:ext cx="3246120" cy="932688"/>
+            <a:off x="320040" y="4078224"/>
+            <a:ext cx="3246120" cy="566928"/>
           </a:xfrm>
           <a:prstGeom prst="rect">
             <a:avLst/>
@@ -1457,9 +1457,9 @@
                 <a:spcPts val="300"/>
               </a:spcAft>
               <a:buNone/>
-              <a:defRPr lang="en-US" sz="850" dirty="0">
-                <a:solidFill>
-                  <a:srgbClr val="222222"/>
+              <a:defRPr lang="en-US" sz="850" i="1" dirty="0">
+                <a:solidFill>
+                  <a:srgbClr val="002516"/>
                 </a:solidFill>
                 <a:latin typeface="Arial" pitchFamily="34" charset="0"/>
                 <a:ea typeface="Arial" pitchFamily="34" charset="-122"/>
@@ -1475,15 +1475,15 @@
               <a:buNone/>
             </a:pPr>
             <a:r>
-              <a:rPr lang="en-US" sz="850" dirty="0">
-                <a:solidFill>
-                  <a:srgbClr val="222222"/>
-                </a:solidFill>
-                <a:latin typeface="Arial" pitchFamily="34" charset="0"/>
-                <a:ea typeface="Arial" pitchFamily="34" charset="-122"/>
-                <a:cs typeface="Arial" pitchFamily="34" charset="-120"/>
-              </a:rPr>
-              <a:t>Method text</a:t>
+              <a:rPr lang="en-US" sz="850" i="1" dirty="0">
+                <a:solidFill>
+                  <a:srgbClr val="002516"/>
+                </a:solidFill>
+                <a:latin typeface="Arial" pitchFamily="34" charset="0"/>
+                <a:ea typeface="Arial" pitchFamily="34" charset="-122"/>
+                <a:cs typeface="Arial" pitchFamily="34" charset="-120"/>
+              </a:rPr>
+              <a:t>A line of feedback, quoted, with its source.</a:t>
             </a:r>
             <a:endParaRPr lang="en-US" sz="850" dirty="0"/>
           </a:p>
@@ -1493,144 +1493,134 @@
         <p:nvSpPr>
           <p:cNvPr id="21" name="Text 11"/>
           <p:cNvSpPr/>
-          <p:nvPr/>
-        </p:nvSpPr>
-        <p:spPr>
-          <a:xfrm>
-            <a:off x="320040" y="3986784"/>
-            <a:ext cx="228600" cy="155448"/>
-          </a:xfrm>
-          <a:prstGeom prst="rect">
-            <a:avLst/>
-          </a:prstGeom>
-          <a:noFill/>
-          <a:ln/>
-        </p:spPr>
-        <p:txBody>
-          <a:bodyPr wrap="square" lIns="0" tIns="0" rIns="0" bIns="0" rtlCol="0" anchor="t"/>
-          <a:lstStyle/>
-          <a:p>
-            <a:pPr indent="0" marL="0">
-              <a:buNone/>
-            </a:pPr>
-            <a:r>
-              <a:rPr lang="en-US" sz="800" b="1" dirty="0">
-                <a:solidFill>
-                  <a:srgbClr val="A89662"/>
-                </a:solidFill>
-                <a:latin typeface="Arial" pitchFamily="34" charset="0"/>
-                <a:ea typeface="Arial" pitchFamily="34" charset="-122"/>
-                <a:cs typeface="Arial" pitchFamily="34" charset="-120"/>
-              </a:rPr>
-              <a:t>04</a:t>
-            </a:r>
-            <a:endParaRPr lang="en-US" sz="800" dirty="0"/>
-          </a:p>
-        </p:txBody>
-      </p:sp>
-      <p:sp>
-        <p:nvSpPr>
-          <p:cNvPr id="22" name="Text 12"/>
-          <p:cNvSpPr/>
-          <p:nvPr/>
-        </p:nvSpPr>
-        <p:spPr>
-          <a:xfrm>
-            <a:off x="548640" y="3986784"/>
-            <a:ext cx="3017520" cy="155448"/>
-          </a:xfrm>
-          <a:prstGeom prst="rect">
-            <a:avLst/>
-          </a:prstGeom>
-          <a:noFill/>
-          <a:ln/>
-        </p:spPr>
-        <p:txBody>
-          <a:bodyPr wrap="square" lIns="0" tIns="0" rIns="0" bIns="0" rtlCol="0" anchor="t"/>
-          <a:lstStyle/>
-          <a:p>
-            <a:pPr indent="0" marL="0">
-              <a:buNone/>
-            </a:pPr>
-            <a:r>
-              <a:rPr lang="en-US" sz="700" b="1" spc="200" kern="0" dirty="0">
-                <a:solidFill>
-                  <a:srgbClr val="002516"/>
-                </a:solidFill>
-                <a:latin typeface="Arial" pitchFamily="34" charset="0"/>
-                <a:ea typeface="Arial" pitchFamily="34" charset="-122"/>
-                <a:cs typeface="Arial" pitchFamily="34" charset="-120"/>
-              </a:rPr>
-              <a:t>END STATE</a:t>
-            </a:r>
-            <a:endParaRPr lang="en-US" sz="700" dirty="0"/>
-          </a:p>
-        </p:txBody>
-      </p:sp>
-      <p:sp>
-        <p:nvSpPr>
-          <p:cNvPr id="23" name="Text 13"/>
-          <p:cNvSpPr/>
           <p:nvPr>
-            <p:ph idx="121" type="body" hasCustomPrompt="1"/>
+            <p:ph idx="119" hasCustomPrompt="1" type="pic"/>
           </p:nvPr>
         </p:nvSpPr>
         <p:spPr>
           <a:xfrm>
-            <a:off x="320040" y="4151376"/>
-            <a:ext cx="3246120" cy="530352"/>
-          </a:xfrm>
-          <a:prstGeom prst="rect">
-            <a:avLst/>
-          </a:prstGeom>
-          <a:noFill/>
-          <a:ln/>
-        </p:spPr>
-        <p:txBody>
-          <a:bodyPr wrap="square" rtlCol="0">
-            <a:normAutofit/>
-          </a:bodyPr>
+            <a:off x="3794760" y="1188720"/>
+            <a:ext cx="2468880" cy="1440180"/>
+          </a:xfrm>
+          <a:prstGeom prst="rect">
+            <a:avLst/>
+          </a:prstGeom>
+          <a:noFill/>
+          <a:ln/>
+        </p:spPr>
+        <p:txBody>
+          <a:bodyPr wrap="square" rtlCol="0"/>
           <a:lstStyle>
             <a:lvl1pPr indent="0" marL="0">
-              <a:spcAft>
-                <a:spcPts val="300"/>
-              </a:spcAft>
-              <a:buNone/>
-              <a:defRPr lang="en-US" sz="850" dirty="0">
-                <a:solidFill>
-                  <a:srgbClr val="222222"/>
-                </a:solidFill>
-                <a:latin typeface="Arial" pitchFamily="34" charset="0"/>
-                <a:ea typeface="Arial" pitchFamily="34" charset="-122"/>
-                <a:cs typeface="Arial" pitchFamily="34" charset="-120"/>
-              </a:defRPr>
+              <a:buNone/>
+              <a:defRPr lang="en-US" dirty="0"/>
             </a:lvl1pPr>
           </a:lstStyle>
           <a:p>
             <a:pPr indent="0" marL="0">
-              <a:spcAft>
-                <a:spcPts val="300"/>
-              </a:spcAft>
-              <a:buNone/>
-            </a:pPr>
-            <a:r>
-              <a:rPr lang="en-US" sz="850" dirty="0">
-                <a:solidFill>
-                  <a:srgbClr val="222222"/>
-                </a:solidFill>
-                <a:latin typeface="Arial" pitchFamily="34" charset="0"/>
-                <a:ea typeface="Arial" pitchFamily="34" charset="-122"/>
-                <a:cs typeface="Arial" pitchFamily="34" charset="-120"/>
-              </a:rPr>
-              <a:t>End state text</a:t>
-            </a:r>
-            <a:endParaRPr lang="en-US" sz="850" dirty="0"/>
-          </a:p>
-        </p:txBody>
-      </p:sp>
-      <p:sp>
-        <p:nvSpPr>
-          <p:cNvPr id="24" name="Text 13"/>
+              <a:buNone/>
+            </a:pPr>
+            <a:r>
+              <a:rPr lang="en-US" dirty="0">
+                <a:solidFill>
+                  <a:srgbClr val="000000"/>
+                </a:solidFill>
+              </a:rPr>
+              <a:t>Photo 1</a:t>
+            </a:r>
+            <a:endParaRPr lang="en-US" dirty="0"/>
+          </a:p>
+        </p:txBody>
+      </p:sp>
+      <p:sp>
+        <p:nvSpPr>
+          <p:cNvPr id="22" name="Text 11"/>
+          <p:cNvSpPr/>
+          <p:nvPr>
+            <p:ph idx="120" hasCustomPrompt="1" type="pic"/>
+          </p:nvPr>
+        </p:nvSpPr>
+        <p:spPr>
+          <a:xfrm>
+            <a:off x="6355080" y="1188720"/>
+            <a:ext cx="2468880" cy="1440180"/>
+          </a:xfrm>
+          <a:prstGeom prst="rect">
+            <a:avLst/>
+          </a:prstGeom>
+          <a:noFill/>
+          <a:ln/>
+        </p:spPr>
+        <p:txBody>
+          <a:bodyPr wrap="square" rtlCol="0"/>
+          <a:lstStyle>
+            <a:lvl1pPr indent="0" marL="0">
+              <a:buNone/>
+              <a:defRPr lang="en-US" dirty="0"/>
+            </a:lvl1pPr>
+          </a:lstStyle>
+          <a:p>
+            <a:pPr indent="0" marL="0">
+              <a:buNone/>
+            </a:pPr>
+            <a:r>
+              <a:rPr lang="en-US" dirty="0">
+                <a:solidFill>
+                  <a:srgbClr val="000000"/>
+                </a:solidFill>
+              </a:rPr>
+              <a:t>Photo 2</a:t>
+            </a:r>
+            <a:endParaRPr lang="en-US" dirty="0"/>
+          </a:p>
+        </p:txBody>
+      </p:sp>
+      <p:sp>
+        <p:nvSpPr>
+          <p:cNvPr id="23" name="Text 11"/>
+          <p:cNvSpPr/>
+          <p:nvPr>
+            <p:ph idx="121" hasCustomPrompt="1" type="pic"/>
+          </p:nvPr>
+        </p:nvSpPr>
+        <p:spPr>
+          <a:xfrm>
+            <a:off x="3794760" y="2720340"/>
+            <a:ext cx="2468880" cy="1440180"/>
+          </a:xfrm>
+          <a:prstGeom prst="rect">
+            <a:avLst/>
+          </a:prstGeom>
+          <a:noFill/>
+          <a:ln/>
+        </p:spPr>
+        <p:txBody>
+          <a:bodyPr wrap="square" rtlCol="0"/>
+          <a:lstStyle>
+            <a:lvl1pPr indent="0" marL="0">
+              <a:buNone/>
+              <a:defRPr lang="en-US" dirty="0"/>
+            </a:lvl1pPr>
+          </a:lstStyle>
+          <a:p>
+            <a:pPr indent="0" marL="0">
+              <a:buNone/>
+            </a:pPr>
+            <a:r>
+              <a:rPr lang="en-US" dirty="0">
+                <a:solidFill>
+                  <a:srgbClr val="000000"/>
+                </a:solidFill>
+              </a:rPr>
+              <a:t>Photo 3</a:t>
+            </a:r>
+            <a:endParaRPr lang="en-US" dirty="0"/>
+          </a:p>
+        </p:txBody>
+      </p:sp>
+      <p:sp>
+        <p:nvSpPr>
+          <p:cNvPr id="24" name="Text 11"/>
           <p:cNvSpPr/>
           <p:nvPr>
             <p:ph idx="122" hasCustomPrompt="1" type="pic"/>
@@ -1638,7 +1628,7 @@
         </p:nvSpPr>
         <p:spPr>
           <a:xfrm>
-            <a:off x="3794760" y="1188720"/>
+            <a:off x="6355080" y="2720340"/>
             <a:ext cx="2468880" cy="1440180"/>
           </a:xfrm>
           <a:prstGeom prst="rect">
@@ -1665,7 +1655,7 @@
                   <a:srgbClr val="000000"/>
                 </a:solidFill>
               </a:rPr>
-              <a:t>Photo 1</a:t>
+              <a:t>Photo 4</a:t>
             </a:r>
             <a:endParaRPr lang="en-US" dirty="0"/>
           </a:p>
@@ -1673,139 +1663,10 @@
       </p:sp>
       <p:sp>
         <p:nvSpPr>
-          <p:cNvPr id="25" name="Text 13"/>
+          <p:cNvPr id="25" name="Text 11"/>
           <p:cNvSpPr/>
           <p:nvPr>
-            <p:ph idx="123" hasCustomPrompt="1" type="pic"/>
-          </p:nvPr>
-        </p:nvSpPr>
-        <p:spPr>
-          <a:xfrm>
-            <a:off x="6355080" y="1188720"/>
-            <a:ext cx="2468880" cy="1440180"/>
-          </a:xfrm>
-          <a:prstGeom prst="rect">
-            <a:avLst/>
-          </a:prstGeom>
-          <a:noFill/>
-          <a:ln/>
-        </p:spPr>
-        <p:txBody>
-          <a:bodyPr wrap="square" rtlCol="0"/>
-          <a:lstStyle>
-            <a:lvl1pPr indent="0" marL="0">
-              <a:buNone/>
-              <a:defRPr lang="en-US" dirty="0"/>
-            </a:lvl1pPr>
-          </a:lstStyle>
-          <a:p>
-            <a:pPr indent="0" marL="0">
-              <a:buNone/>
-            </a:pPr>
-            <a:r>
-              <a:rPr lang="en-US" dirty="0">
-                <a:solidFill>
-                  <a:srgbClr val="000000"/>
-                </a:solidFill>
-              </a:rPr>
-              <a:t>Photo 2</a:t>
-            </a:r>
-            <a:endParaRPr lang="en-US" dirty="0"/>
-          </a:p>
-        </p:txBody>
-      </p:sp>
-      <p:sp>
-        <p:nvSpPr>
-          <p:cNvPr id="26" name="Text 13"/>
-          <p:cNvSpPr/>
-          <p:nvPr>
-            <p:ph idx="124" hasCustomPrompt="1" type="pic"/>
-          </p:nvPr>
-        </p:nvSpPr>
-        <p:spPr>
-          <a:xfrm>
-            <a:off x="3794760" y="2720340"/>
-            <a:ext cx="2468880" cy="1440180"/>
-          </a:xfrm>
-          <a:prstGeom prst="rect">
-            <a:avLst/>
-          </a:prstGeom>
-          <a:noFill/>
-          <a:ln/>
-        </p:spPr>
-        <p:txBody>
-          <a:bodyPr wrap="square" rtlCol="0"/>
-          <a:lstStyle>
-            <a:lvl1pPr indent="0" marL="0">
-              <a:buNone/>
-              <a:defRPr lang="en-US" dirty="0"/>
-            </a:lvl1pPr>
-          </a:lstStyle>
-          <a:p>
-            <a:pPr indent="0" marL="0">
-              <a:buNone/>
-            </a:pPr>
-            <a:r>
-              <a:rPr lang="en-US" dirty="0">
-                <a:solidFill>
-                  <a:srgbClr val="000000"/>
-                </a:solidFill>
-              </a:rPr>
-              <a:t>Photo 3</a:t>
-            </a:r>
-            <a:endParaRPr lang="en-US" dirty="0"/>
-          </a:p>
-        </p:txBody>
-      </p:sp>
-      <p:sp>
-        <p:nvSpPr>
-          <p:cNvPr id="27" name="Text 13"/>
-          <p:cNvSpPr/>
-          <p:nvPr>
-            <p:ph idx="125" hasCustomPrompt="1" type="pic"/>
-          </p:nvPr>
-        </p:nvSpPr>
-        <p:spPr>
-          <a:xfrm>
-            <a:off x="6355080" y="2720340"/>
-            <a:ext cx="2468880" cy="1440180"/>
-          </a:xfrm>
-          <a:prstGeom prst="rect">
-            <a:avLst/>
-          </a:prstGeom>
-          <a:noFill/>
-          <a:ln/>
-        </p:spPr>
-        <p:txBody>
-          <a:bodyPr wrap="square" rtlCol="0"/>
-          <a:lstStyle>
-            <a:lvl1pPr indent="0" marL="0">
-              <a:buNone/>
-              <a:defRPr lang="en-US" dirty="0"/>
-            </a:lvl1pPr>
-          </a:lstStyle>
-          <a:p>
-            <a:pPr indent="0" marL="0">
-              <a:buNone/>
-            </a:pPr>
-            <a:r>
-              <a:rPr lang="en-US" dirty="0">
-                <a:solidFill>
-                  <a:srgbClr val="000000"/>
-                </a:solidFill>
-              </a:rPr>
-              <a:t>Photo 4</a:t>
-            </a:r>
-            <a:endParaRPr lang="en-US" dirty="0"/>
-          </a:p>
-        </p:txBody>
-      </p:sp>
-      <p:sp>
-        <p:nvSpPr>
-          <p:cNvPr id="28" name="Text 13"/>
-          <p:cNvSpPr/>
-          <p:nvPr>
-            <p:ph idx="126" type="body" hasCustomPrompt="1"/>
+            <p:ph idx="123" type="body" hasCustomPrompt="1"/>
           </p:nvPr>
         </p:nvSpPr>
         <p:spPr>
@@ -2453,7 +2314,7 @@
         <p:spPr>
           <a:xfrm>
             <a:off x="320040" y="1353312"/>
-            <a:ext cx="3246120" cy="530352"/>
+            <a:ext cx="3246120" cy="640080"/>
           </a:xfrm>
           <a:prstGeom prst="rect">
             <a:avLst/>
@@ -2482,7 +2343,7 @@
                 <a:ea typeface="Arial" pitchFamily="34" charset="-122"/>
                 <a:cs typeface="Arial" pitchFamily="34" charset="-120"/>
               </a:rPr>
-              <a:t>NZALC delivered ELDA Lead Systems to 27 NZ Army and Australian Defence Force personnel from 7 to 14 August 2026. The activity was a three-day rogaine culminating in a whitewater rafting descent.</a:t>
+              <a:t>To enhance leadership and warrior ethos through the conduct of a challenging multisport activity, supported by leadership tools, psychometrics, reflection and behaviour selection.</a:t>
             </a:r>
             <a:endParaRPr lang="en-US" sz="850" dirty="0"/>
           </a:p>
@@ -2498,7 +2359,96 @@
         </p:nvSpPr>
         <p:spPr>
           <a:xfrm>
-            <a:off x="320040" y="2139696"/>
+            <a:off x="320040" y="2249424"/>
+            <a:ext cx="3246120" cy="1572768"/>
+          </a:xfrm>
+          <a:prstGeom prst="rect">
+            <a:avLst/>
+          </a:prstGeom>
+          <a:noFill/>
+          <a:ln/>
+        </p:spPr>
+        <p:txBody>
+          <a:bodyPr wrap="square" lIns="0" tIns="0" rIns="0" bIns="0" rtlCol="0" anchor="t">
+            <a:normAutofit/>
+          </a:bodyPr>
+          <a:lstStyle/>
+          <a:p>
+            <a:pPr marL="114300" indent="-114300">
+              <a:spcAft>
+                <a:spcPts val="300"/>
+              </a:spcAft>
+              <a:buSzPct val="100000"/>
+              <a:buChar char="•"/>
+            </a:pPr>
+            <a:r>
+              <a:rPr lang="en-US" sz="850" b="1" dirty="0">
+                <a:solidFill>
+                  <a:srgbClr val="222222"/>
+                </a:solidFill>
+                <a:latin typeface="Arial" pitchFamily="34" charset="0"/>
+                <a:ea typeface="Arial" pitchFamily="34" charset="-122"/>
+                <a:cs typeface="Arial" pitchFamily="34" charset="-120"/>
+              </a:rPr>
+              <a:t>27 NZ Army and Australian Defence Force personnel completed ELDA Lead Systems together, strengthening joint leadership development ties.</a:t>
+            </a:r>
+            <a:endParaRPr lang="en-US" sz="850" dirty="0"/>
+          </a:p>
+          <a:p>
+            <a:pPr marL="114300" indent="-114300">
+              <a:spcAft>
+                <a:spcPts val="300"/>
+              </a:spcAft>
+              <a:buSzPct val="100000"/>
+              <a:buChar char="•"/>
+            </a:pPr>
+            <a:r>
+              <a:rPr lang="en-US" sz="850" dirty="0">
+                <a:solidFill>
+                  <a:srgbClr val="222222"/>
+                </a:solidFill>
+                <a:latin typeface="Arial" pitchFamily="34" charset="0"/>
+                <a:ea typeface="Arial" pitchFamily="34" charset="-122"/>
+                <a:cs typeface="Arial" pitchFamily="34" charset="-120"/>
+              </a:rPr>
+              <a:t>The three-day rogaine, culminating in a whitewater rafting descent, forced planning and execution against incomplete information: direct evidence of resilience, judgement and teamwork under pressure.</a:t>
+            </a:r>
+            <a:endParaRPr lang="en-US" sz="850" dirty="0"/>
+          </a:p>
+          <a:p>
+            <a:pPr marL="114300" indent="-114300">
+              <a:spcAft>
+                <a:spcPts val="300"/>
+              </a:spcAft>
+              <a:buSzPct val="100000"/>
+              <a:buChar char="•"/>
+            </a:pPr>
+            <a:r>
+              <a:rPr lang="en-US" sz="850" dirty="0">
+                <a:solidFill>
+                  <a:srgbClr val="222222"/>
+                </a:solidFill>
+                <a:latin typeface="Arial" pitchFamily="34" charset="0"/>
+                <a:ea typeface="Arial" pitchFamily="34" charset="-122"/>
+                <a:cs typeface="Arial" pitchFamily="34" charset="-120"/>
+              </a:rPr>
+              <a:t>Leadership diagnostics, structured debriefs and individual Leadership Development Plans converted reflection into readiness, building the combat mindset required at lead systems level.</a:t>
+            </a:r>
+            <a:endParaRPr lang="en-US" sz="850" dirty="0"/>
+          </a:p>
+        </p:txBody>
+      </p:sp>
+      <p:sp>
+        <p:nvSpPr>
+          <p:cNvPr id="7" name="Text 11"/>
+          <p:cNvSpPr/>
+          <p:nvPr>
+            <p:ph idx="118" type="body" hasCustomPrompt="1"/>
+          </p:nvPr>
+        </p:nvSpPr>
+        <p:spPr>
+          <a:xfrm>
+            <a:off x="320040" y="4078224"/>
             <a:ext cx="3246120" cy="566928"/>
           </a:xfrm>
           <a:prstGeom prst="rect">
@@ -2520,45 +2470,16 @@
               <a:buNone/>
             </a:pPr>
             <a:r>
-              <a:rPr lang="en-US" sz="850" dirty="0">
-                <a:solidFill>
-                  <a:srgbClr val="222222"/>
-                </a:solidFill>
-                <a:latin typeface="Arial" pitchFamily="34" charset="0"/>
-                <a:ea typeface="Arial" pitchFamily="34" charset="-122"/>
-                <a:cs typeface="Arial" pitchFamily="34" charset="-120"/>
-              </a:rPr>
-              <a:t>To enhance leadership and warrior ethos through the conduct of a challenging multisport activity, supported by leadership tools, psychometrics, reflection and behaviour selection.</a:t>
-            </a:r>
-            <a:endParaRPr lang="en-US" sz="850" dirty="0"/>
-          </a:p>
-        </p:txBody>
-      </p:sp>
-      <p:sp>
-        <p:nvSpPr>
-          <p:cNvPr id="7" name="Text 11"/>
-          <p:cNvSpPr/>
-          <p:nvPr>
-            <p:ph idx="118" type="body" hasCustomPrompt="1"/>
-          </p:nvPr>
-        </p:nvSpPr>
-        <p:spPr>
-          <a:xfrm>
-            <a:off x="320040" y="2962656"/>
-            <a:ext cx="3246120" cy="932688"/>
-          </a:xfrm>
-          <a:prstGeom prst="rect">
-            <a:avLst/>
-          </a:prstGeom>
-          <a:noFill/>
-          <a:ln/>
-        </p:spPr>
-        <p:txBody>
-          <a:bodyPr wrap="square" lIns="0" tIns="0" rIns="0" bIns="0" rtlCol="0" anchor="t">
-            <a:normAutofit/>
-          </a:bodyPr>
-          <a:lstStyle/>
-          <a:p>
+              <a:rPr lang="en-US" sz="850" i="1" dirty="0">
+                <a:solidFill>
+                  <a:srgbClr val="002516"/>
+                </a:solidFill>
+                <a:latin typeface="Arial" pitchFamily="34" charset="0"/>
+                <a:ea typeface="Arial" pitchFamily="34" charset="-122"/>
+                <a:cs typeface="Arial" pitchFamily="34" charset="-120"/>
+              </a:rPr>
+              <a:t>“An excellent course that required a high level of personal drive and commitment, whilst also reinforcing the importance of working as a team towards a common goal.” </a:t>
+            </a:r>
             <a:pPr indent="0" marL="0">
               <a:spcAft>
                 <a:spcPts val="300"/>
@@ -2566,98 +2487,15 @@
               <a:buNone/>
             </a:pPr>
             <a:r>
-              <a:rPr lang="en-US" sz="850" dirty="0">
-                <a:solidFill>
-                  <a:srgbClr val="222222"/>
-                </a:solidFill>
-                <a:latin typeface="Arial" pitchFamily="34" charset="0"/>
-                <a:ea typeface="Arial" pitchFamily="34" charset="-122"/>
-                <a:cs typeface="Arial" pitchFamily="34" charset="-120"/>
-              </a:rPr>
-              <a:t>The rogaine forced planning and execution against incomplete information, giving direct evidence of resilience, judgement and teamwork under pressure.</a:t>
-            </a:r>
-            <a:endParaRPr lang="en-US" sz="850" dirty="0"/>
-          </a:p>
-          <a:p>
-            <a:pPr indent="0" marL="0">
-              <a:spcAft>
-                <a:spcPts val="300"/>
-              </a:spcAft>
-              <a:buNone/>
-            </a:pPr>
-            <a:r>
-              <a:rPr lang="en-US" sz="850" dirty="0">
-                <a:solidFill>
-                  <a:srgbClr val="222222"/>
-                </a:solidFill>
-                <a:latin typeface="Arial" pitchFamily="34" charset="0"/>
-                <a:ea typeface="Arial" pitchFamily="34" charset="-122"/>
-                <a:cs typeface="Arial" pitchFamily="34" charset="-120"/>
-              </a:rPr>
-              <a:t>Leadership diagnostics, structured debriefs and individual Leadership Development Plans converted reflection into readiness, building the combat mindset required at lead systems level. Training alongside ADF personnel strengthened joint leadership development ties.</a:t>
-            </a:r>
-            <a:endParaRPr lang="en-US" sz="850" dirty="0"/>
-          </a:p>
-        </p:txBody>
-      </p:sp>
-      <p:sp>
-        <p:nvSpPr>
-          <p:cNvPr id="8" name="Text 13"/>
-          <p:cNvSpPr/>
-          <p:nvPr>
-            <p:ph idx="121" type="body" hasCustomPrompt="1"/>
-          </p:nvPr>
-        </p:nvSpPr>
-        <p:spPr>
-          <a:xfrm>
-            <a:off x="320040" y="4151376"/>
-            <a:ext cx="3246120" cy="530352"/>
-          </a:xfrm>
-          <a:prstGeom prst="rect">
-            <a:avLst/>
-          </a:prstGeom>
-          <a:noFill/>
-          <a:ln/>
-        </p:spPr>
-        <p:txBody>
-          <a:bodyPr wrap="square" lIns="0" tIns="0" rIns="0" bIns="0" rtlCol="0" anchor="t">
-            <a:normAutofit/>
-          </a:bodyPr>
-          <a:lstStyle/>
-          <a:p>
-            <a:pPr indent="0" marL="0">
-              <a:spcAft>
-                <a:spcPts val="300"/>
-              </a:spcAft>
-              <a:buNone/>
-            </a:pPr>
-            <a:r>
-              <a:rPr lang="en-US" sz="850" dirty="0">
-                <a:solidFill>
-                  <a:srgbClr val="222222"/>
-                </a:solidFill>
-                <a:latin typeface="Arial" pitchFamily="34" charset="0"/>
-                <a:ea typeface="Arial" pitchFamily="34" charset="-122"/>
-                <a:cs typeface="Arial" pitchFamily="34" charset="-120"/>
-              </a:rPr>
-              <a:t>All personnel completed ELDA Lead Systems. Student evaluations indicate a well-conducted course. </a:t>
-            </a:r>
-            <a:pPr indent="0" marL="0">
-              <a:spcAft>
-                <a:spcPts val="300"/>
-              </a:spcAft>
-              <a:buNone/>
-            </a:pPr>
-            <a:r>
               <a:rPr lang="en-US" sz="850" i="1" dirty="0">
                 <a:solidFill>
-                  <a:srgbClr val="002516"/>
-                </a:solidFill>
-                <a:latin typeface="Arial" pitchFamily="34" charset="0"/>
-                <a:ea typeface="Arial" pitchFamily="34" charset="-122"/>
-                <a:cs typeface="Arial" pitchFamily="34" charset="-120"/>
-              </a:rPr>
-              <a:t>“An excellent course that required a high level of personal drive and commitment, whilst also reinforcing the importance of working as a team towards a common goal.”</a:t>
+                  <a:srgbClr val="5F5F5A"/>
+                </a:solidFill>
+                <a:latin typeface="Arial" pitchFamily="34" charset="0"/>
+                <a:ea typeface="Arial" pitchFamily="34" charset="-122"/>
+                <a:cs typeface="Arial" pitchFamily="34" charset="-120"/>
+              </a:rPr>
+              <a:t>Student evaluation</a:t>
             </a:r>
             <a:endParaRPr lang="en-US" sz="850" dirty="0"/>
           </a:p>
@@ -2665,7 +2503,7 @@
       </p:sp>
       <p:pic>
         <p:nvPicPr>
-          <p:cNvPr id="9" name="Image 1" descr="preencoded.png">    </p:cNvPr>
+          <p:cNvPr id="8" name="Image 1" descr="preencoded.png">    </p:cNvPr>
           <p:cNvPicPr>
             <a:picLocks noChangeAspect="1"/>
           </p:cNvPicPr>
@@ -2689,7 +2527,7 @@
       </p:pic>
       <p:pic>
         <p:nvPicPr>
-          <p:cNvPr id="10" name="Image 2" descr="preencoded.png">    </p:cNvPr>
+          <p:cNvPr id="9" name="Image 2" descr="preencoded.png">    </p:cNvPr>
           <p:cNvPicPr>
             <a:picLocks noChangeAspect="1"/>
           </p:cNvPicPr>
@@ -2713,7 +2551,7 @@
       </p:pic>
       <p:pic>
         <p:nvPicPr>
-          <p:cNvPr id="11" name="Image 3" descr="preencoded.png">    </p:cNvPr>
+          <p:cNvPr id="10" name="Image 3" descr="preencoded.png">    </p:cNvPr>
           <p:cNvPicPr>
             <a:picLocks noChangeAspect="1"/>
           </p:cNvPicPr>
@@ -2737,7 +2575,7 @@
       </p:pic>
       <p:pic>
         <p:nvPicPr>
-          <p:cNvPr id="12" name="Image 4" descr="preencoded.png">    </p:cNvPr>
+          <p:cNvPr id="11" name="Image 4" descr="preencoded.png">    </p:cNvPr>
           <p:cNvPicPr>
             <a:picLocks noChangeAspect="1"/>
           </p:cNvPicPr>
@@ -2761,7 +2599,7 @@
       </p:pic>
       <p:sp>
         <p:nvSpPr>
-          <p:cNvPr id="13" name="Shape 6"/>
+          <p:cNvPr id="12" name="Shape 5"/>
           <p:cNvSpPr/>
           <p:nvPr/>
         </p:nvSpPr>
@@ -2786,7 +2624,7 @@
       </p:sp>
       <p:sp>
         <p:nvSpPr>
-          <p:cNvPr id="14" name="Text 7"/>
+          <p:cNvPr id="13" name="Text 6"/>
           <p:cNvSpPr txBox="1"/>
           <p:nvPr/>
         </p:nvSpPr>
@@ -2825,7 +2663,7 @@
       </p:sp>
       <p:sp>
         <p:nvSpPr>
-          <p:cNvPr id="15" name="Shape 8"/>
+          <p:cNvPr id="14" name="Shape 7"/>
           <p:cNvSpPr/>
           <p:nvPr/>
         </p:nvSpPr>
@@ -2850,7 +2688,7 @@
       </p:sp>
       <p:sp>
         <p:nvSpPr>
-          <p:cNvPr id="16" name="Text 9"/>
+          <p:cNvPr id="15" name="Text 8"/>
           <p:cNvSpPr txBox="1"/>
           <p:nvPr/>
         </p:nvSpPr>
@@ -2889,7 +2727,7 @@
       </p:sp>
       <p:sp>
         <p:nvSpPr>
-          <p:cNvPr id="17" name="Shape 10"/>
+          <p:cNvPr id="16" name="Shape 9"/>
           <p:cNvSpPr/>
           <p:nvPr/>
         </p:nvSpPr>
@@ -2914,7 +2752,7 @@
       </p:sp>
       <p:sp>
         <p:nvSpPr>
-          <p:cNvPr id="18" name="Text 11"/>
+          <p:cNvPr id="17" name="Text 10"/>
           <p:cNvSpPr txBox="1"/>
           <p:nvPr/>
         </p:nvSpPr>
@@ -2953,7 +2791,7 @@
       </p:sp>
       <p:sp>
         <p:nvSpPr>
-          <p:cNvPr id="19" name="Shape 12"/>
+          <p:cNvPr id="18" name="Shape 11"/>
           <p:cNvSpPr/>
           <p:nvPr/>
         </p:nvSpPr>
@@ -2978,7 +2816,7 @@
       </p:sp>
       <p:sp>
         <p:nvSpPr>
-          <p:cNvPr id="20" name="Text 13"/>
+          <p:cNvPr id="19" name="Text 12"/>
           <p:cNvSpPr txBox="1"/>
           <p:nvPr/>
         </p:nvSpPr>
@@ -3017,10 +2855,10 @@
       </p:sp>
       <p:sp>
         <p:nvSpPr>
-          <p:cNvPr id="21" name="Text 13"/>
+          <p:cNvPr id="20" name="Text 11"/>
           <p:cNvSpPr/>
           <p:nvPr>
-            <p:ph idx="126" type="body" hasCustomPrompt="1"/>
+            <p:ph idx="123" type="body" hasCustomPrompt="1"/>
           </p:nvPr>
         </p:nvSpPr>
         <p:spPr>
@@ -3158,7 +2996,7 @@
       </p:sp>
       <p:sp>
         <p:nvSpPr>
-          <p:cNvPr id="22" name="Text 15"/>
+          <p:cNvPr id="21" name="Text 14"/>
           <p:cNvSpPr txBox="1"/>
           <p:nvPr/>
         </p:nvSpPr>
@@ -3203,7 +3041,7 @@
       </p:sp>
       <p:sp>
         <p:nvSpPr>
-          <p:cNvPr id="24" name="Text 3"/>
+          <p:cNvPr id="23" name="Text 3"/>
           <p:cNvSpPr/>
           <p:nvPr>
             <p:ph idx="106" hasCustomPrompt="1"/>
@@ -3235,10 +3073,10 @@
       </p:sp>
       <p:sp>
         <p:nvSpPr>
-          <p:cNvPr id="25" name="Text 13"/>
+          <p:cNvPr id="24" name="Text 11"/>
           <p:cNvSpPr/>
           <p:nvPr>
-            <p:ph idx="122" hasCustomPrompt="1"/>
+            <p:ph idx="119" hasCustomPrompt="1"/>
           </p:nvPr>
         </p:nvSpPr>
         <p:spPr>
@@ -3267,10 +3105,10 @@
       </p:sp>
       <p:sp>
         <p:nvSpPr>
-          <p:cNvPr id="26" name="Text 13"/>
+          <p:cNvPr id="25" name="Text 11"/>
           <p:cNvSpPr/>
           <p:nvPr>
-            <p:ph idx="123" hasCustomPrompt="1"/>
+            <p:ph idx="120" hasCustomPrompt="1"/>
           </p:nvPr>
         </p:nvSpPr>
         <p:spPr>
@@ -3299,10 +3137,10 @@
       </p:sp>
       <p:sp>
         <p:nvSpPr>
-          <p:cNvPr id="27" name="Text 13"/>
+          <p:cNvPr id="26" name="Text 11"/>
           <p:cNvSpPr/>
           <p:nvPr>
-            <p:ph idx="124" hasCustomPrompt="1"/>
+            <p:ph idx="121" hasCustomPrompt="1"/>
           </p:nvPr>
         </p:nvSpPr>
         <p:spPr>
@@ -3331,10 +3169,10 @@
       </p:sp>
       <p:sp>
         <p:nvSpPr>
-          <p:cNvPr id="28" name="Text 13"/>
+          <p:cNvPr id="27" name="Text 11"/>
           <p:cNvSpPr/>
           <p:nvPr>
-            <p:ph idx="125" hasCustomPrompt="1"/>
+            <p:ph idx="122" hasCustomPrompt="1"/>
           </p:nvPr>
         </p:nvSpPr>
         <p:spPr>
@@ -4555,7 +4393,7 @@
                 <a:ea typeface="Arial" pitchFamily="34" charset="-122"/>
                 <a:cs typeface="Arial" pitchFamily="34" charset="-120"/>
               </a:rPr>
-              <a:t>Introduction, purpose, method and end state. Each field shrinks to fit; keep the board to one page.</a:t>
+              <a:t>Purpose, then delivery and effect in three or four points, then a line of participant feedback. Each field shrinks to fit.</a:t>
             </a:r>
             <a:endParaRPr lang="en-US" sz="750" dirty="0"/>
           </a:p>
@@ -5430,24 +5268,43 @@
       </p:sp>
       <p:sp>
         <p:nvSpPr>
-          <p:cNvPr id="8" name="Text Placeholder 7"/>
+          <p:cNvPr id="8" name="Picture Placeholder 7"/>
           <p:cNvSpPr>
             <a:spLocks noGrp="1"/>
           </p:cNvSpPr>
           <p:nvPr>
-            <p:ph type="body" idx="121"/>
+            <p:ph type="pic" idx="119"/>
           </p:nvPr>
         </p:nvSpPr>
         <p:spPr/>
-        <p:txBody>
-          <a:bodyPr/>
-          <a:lstStyle/>
-          <a:p/>
-        </p:txBody>
       </p:sp>
       <p:sp>
         <p:nvSpPr>
           <p:cNvPr id="9" name="Picture Placeholder 8"/>
+          <p:cNvSpPr>
+            <a:spLocks noGrp="1"/>
+          </p:cNvSpPr>
+          <p:nvPr>
+            <p:ph type="pic" idx="120"/>
+          </p:nvPr>
+        </p:nvSpPr>
+        <p:spPr/>
+      </p:sp>
+      <p:sp>
+        <p:nvSpPr>
+          <p:cNvPr id="10" name="Picture Placeholder 9"/>
+          <p:cNvSpPr>
+            <a:spLocks noGrp="1"/>
+          </p:cNvSpPr>
+          <p:nvPr>
+            <p:ph type="pic" idx="121"/>
+          </p:nvPr>
+        </p:nvSpPr>
+        <p:spPr/>
+      </p:sp>
+      <p:sp>
+        <p:nvSpPr>
+          <p:cNvPr id="11" name="Picture Placeholder 10"/>
           <p:cNvSpPr>
             <a:spLocks noGrp="1"/>
           </p:cNvSpPr>
@@ -5459,51 +5316,15 @@
       </p:sp>
       <p:sp>
         <p:nvSpPr>
-          <p:cNvPr id="10" name="Picture Placeholder 9"/>
+          <p:cNvPr id="12" name="Text Placeholder 11"/>
           <p:cNvSpPr>
             <a:spLocks noGrp="1"/>
           </p:cNvSpPr>
           <p:nvPr>
-            <p:ph type="pic" idx="123"/>
+            <p:ph type="body" idx="123"/>
           </p:nvPr>
         </p:nvSpPr>
         <p:spPr/>
-      </p:sp>
-      <p:sp>
-        <p:nvSpPr>
-          <p:cNvPr id="11" name="Picture Placeholder 10"/>
-          <p:cNvSpPr>
-            <a:spLocks noGrp="1"/>
-          </p:cNvSpPr>
-          <p:nvPr>
-            <p:ph type="pic" idx="124"/>
-          </p:nvPr>
-        </p:nvSpPr>
-        <p:spPr/>
-      </p:sp>
-      <p:sp>
-        <p:nvSpPr>
-          <p:cNvPr id="12" name="Picture Placeholder 11"/>
-          <p:cNvSpPr>
-            <a:spLocks noGrp="1"/>
-          </p:cNvSpPr>
-          <p:nvPr>
-            <p:ph type="pic" idx="125"/>
-          </p:nvPr>
-        </p:nvSpPr>
-        <p:spPr/>
-      </p:sp>
-      <p:sp>
-        <p:nvSpPr>
-          <p:cNvPr id="13" name="Text Placeholder 12"/>
-          <p:cNvSpPr>
-            <a:spLocks noGrp="1"/>
-          </p:cNvSpPr>
-          <p:nvPr>
-            <p:ph type="body" idx="126"/>
-          </p:nvPr>
-        </p:nvSpPr>
-        <p:spPr/>
         <p:txBody>
           <a:bodyPr/>
           <a:lstStyle/>
@@ -5512,7 +5333,7 @@
       </p:sp>
       <p:sp>
         <p:nvSpPr>
-          <p:cNvPr id="14" name="Photo 1 number"/>
+          <p:cNvPr id="13" name="Photo 1 number"/>
           <p:cNvSpPr/>
           <p:nvPr/>
         </p:nvSpPr>
@@ -5565,7 +5386,7 @@
       </p:sp>
       <p:sp>
         <p:nvSpPr>
-          <p:cNvPr id="15" name="Photo 2 number"/>
+          <p:cNvPr id="14" name="Photo 2 number"/>
           <p:cNvSpPr/>
           <p:nvPr/>
         </p:nvSpPr>
@@ -5618,7 +5439,7 @@
       </p:sp>
       <p:sp>
         <p:nvSpPr>
-          <p:cNvPr id="16" name="Photo 3 number"/>
+          <p:cNvPr id="15" name="Photo 3 number"/>
           <p:cNvSpPr/>
           <p:nvPr/>
         </p:nvSpPr>
@@ -5671,7 +5492,7 @@
       </p:sp>
       <p:sp>
         <p:nvSpPr>
-          <p:cNvPr id="17" name="Photo 4 number"/>
+          <p:cNvPr id="16" name="Photo 4 number"/>
           <p:cNvSpPr/>
           <p:nvPr/>
         </p:nvSpPr>

</xml_diff>

<commit_message>
ATG storyboard: second worked example from the previous template's board
Lead Leaders rock-climbing ELDA content and photographs recast into the
storyboard format; example slides now built from one function.

Co-Authored-By: Claude Fable 5.1 <noreply@anthropic.com>
Claude-Session: https://claude.ai/code/session_01LgFPs3fMSncBgbYQ3PfA3o
</commit_message>
<xml_diff>
--- a/output/atg-storyboard-template.pptx
+++ b/output/atg-storyboard-template.pptx
@@ -5,12 +5,13 @@
     <p:sldMasterId id="2147483648" r:id="rId1"/>
   </p:sldMasterIdLst>
   <p:sldIdLst>
-    <p:sldId id="258" r:id="rId9"/>
+    <p:sldId id="259" r:id="rId10"/>
     <p:sldId id="256" r:id="rId2"/>
     <p:sldId id="257" r:id="rId3"/>
+    <p:sldId id="258" r:id="rId4"/>
   </p:sldIdLst>
   <p:notesMasterIdLst>
-    <p:notesMasterId r:id="rId4"/>
+    <p:notesMasterId r:id="rId5"/>
   </p:notesMasterIdLst>
   <p:sldSz cx="9144000" cy="5143500"/>
   <p:notesSz cx="5143500" cy="9144000"/>
@@ -592,7 +593,7 @@
           <a:p>
             <a:r>
               <a:rPr lang="en-US" dirty="0"/>
-              <a:t>Submission flow as issued by ATG on 13 Oct 25. Unit badges carried over from the previous template.</a:t>
+              <a:t>Second worked example, from the example board in the previous ATG template (Lead Leaders rock-climbing ELDA). The source carried no dates, so the activity line names the locations; photo captions are illustrative.</a:t>
             </a:r>
             <a:endParaRPr lang="en-US" dirty="0"/>
           </a:p>
@@ -616,6 +617,94 @@
             <a:fld id="{F7021451-1387-4CA6-816F-3879F97B5CBC}" type="slidenum">
               <a:rPr lang="en-US"/>
               <a:t>2</a:t>
+            </a:fld>
+            <a:endParaRPr lang="en-US"/>
+          </a:p>
+        </p:txBody>
+      </p:sp>
+    </p:spTree>
+    <p:extLst>
+      <p:ext uri="{BB962C8B-B14F-4D97-AF65-F5344CB8AC3E}">
+        <p14:creationId xmlns:p14="http://schemas.microsoft.com/office/powerpoint/2010/main" val="1024086991"/>
+      </p:ext>
+    </p:extLst>
+  </p:cSld>
+  <p:clrMapOvr>
+    <a:masterClrMapping/>
+  </p:clrMapOvr>
+</p:notes>
+</file>
+
+<file path=ppt/notesSlides/notesSlide3.xml><?xml version="1.0" encoding="utf-8"?>
+<p:notes xmlns:a="http://schemas.openxmlformats.org/drawingml/2006/main" xmlns:r="http://schemas.openxmlformats.org/officeDocument/2006/relationships" xmlns:p="http://schemas.openxmlformats.org/presentationml/2006/main">
+  <p:cSld>
+    <p:spTree>
+      <p:nvGrpSpPr>
+        <p:cNvPr id="1" name=""/>
+        <p:cNvGrpSpPr/>
+        <p:nvPr/>
+      </p:nvGrpSpPr>
+      <p:grpSpPr>
+        <a:xfrm>
+          <a:off x="0" y="0"/>
+          <a:ext cx="0" cy="0"/>
+          <a:chOff x="0" y="0"/>
+          <a:chExt cx="0" cy="0"/>
+        </a:xfrm>
+      </p:grpSpPr>
+      <p:sp>
+        <p:nvSpPr>
+          <p:cNvPr id="2" name="Slide Image Placeholder 1"/>
+          <p:cNvSpPr>
+            <a:spLocks noGrp="1" noRot="1" noChangeAspect="1"/>
+          </p:cNvSpPr>
+          <p:nvPr>
+            <p:ph type="sldImg"/>
+          </p:nvPr>
+        </p:nvSpPr>
+        <p:spPr/>
+      </p:sp>
+      <p:sp>
+        <p:nvSpPr>
+          <p:cNvPr id="3" name="Notes Placeholder 2"/>
+          <p:cNvSpPr>
+            <a:spLocks noGrp="1"/>
+          </p:cNvSpPr>
+          <p:nvPr>
+            <p:ph type="body" idx="1"/>
+          </p:nvPr>
+        </p:nvSpPr>
+        <p:spPr/>
+        <p:txBody>
+          <a:bodyPr/>
+          <a:lstStyle/>
+          <a:p>
+            <a:r>
+              <a:rPr lang="en-US" dirty="0"/>
+              <a:t>Submission flow as issued by ATG on 13 Oct 25. Unit badges carried over from the previous template.</a:t>
+            </a:r>
+            <a:endParaRPr lang="en-US" dirty="0"/>
+          </a:p>
+        </p:txBody>
+      </p:sp>
+      <p:sp>
+        <p:nvSpPr>
+          <p:cNvPr id="4" name="Slide Number Placeholder 3"/>
+          <p:cNvSpPr>
+            <a:spLocks noGrp="1"/>
+          </p:cNvSpPr>
+          <p:nvPr>
+            <p:ph type="sldNum" sz="quarter" idx="10"/>
+          </p:nvPr>
+        </p:nvSpPr>
+        <p:spPr/>
+        <p:txBody>
+          <a:bodyPr/>
+          <a:lstStyle/>
+          <a:p>
+            <a:fld id="{F7021451-1387-4CA6-816F-3879F97B5CBC}" type="slidenum">
+              <a:rPr lang="en-US"/>
+              <a:t>3</a:t>
             </a:fld>
             <a:endParaRPr lang="en-US"/>
           </a:p>
@@ -3226,6 +3315,1037 @@
       </p:grpSpPr>
       <p:sp>
         <p:nvSpPr>
+          <p:cNvPr id="2" name="Text 3"/>
+          <p:cNvSpPr/>
+          <p:nvPr>
+            <p:ph idx="104" type="title" hasCustomPrompt="1"/>
+          </p:nvPr>
+        </p:nvSpPr>
+        <p:spPr>
+          <a:xfrm>
+            <a:off x="1234440" y="429768"/>
+            <a:ext cx="6629400" cy="292608"/>
+          </a:xfrm>
+          <a:prstGeom prst="rect">
+            <a:avLst/>
+          </a:prstGeom>
+          <a:noFill/>
+          <a:ln/>
+        </p:spPr>
+        <p:txBody>
+          <a:bodyPr wrap="square" lIns="0" tIns="0" rIns="0" bIns="0" rtlCol="0" anchor="ctr">
+            <a:normAutofit/>
+          </a:bodyPr>
+          <a:lstStyle/>
+          <a:p>
+            <a:pPr algn="l" indent="0" marL="0">
+              <a:buNone/>
+            </a:pPr>
+            <a:r>
+              <a:rPr lang="en-US" sz="1600" b="1" dirty="0">
+                <a:solidFill>
+                  <a:srgbClr val="000000"/>
+                </a:solidFill>
+                <a:latin typeface="Arial" pitchFamily="34" charset="0"/>
+                <a:ea typeface="Arial" pitchFamily="34" charset="-122"/>
+                <a:cs typeface="Arial" pitchFamily="34" charset="-120"/>
+              </a:rPr>
+              <a:t>Army Command School  ·  NZ Army Leadership Centre</a:t>
+            </a:r>
+            <a:endParaRPr lang="en-US" sz="1600" dirty="0"/>
+          </a:p>
+        </p:txBody>
+      </p:sp>
+      <p:sp>
+        <p:nvSpPr>
+          <p:cNvPr id="3" name="Text 3"/>
+          <p:cNvSpPr/>
+          <p:nvPr>
+            <p:ph idx="105" type="body" hasCustomPrompt="1"/>
+          </p:nvPr>
+        </p:nvSpPr>
+        <p:spPr>
+          <a:xfrm>
+            <a:off x="1234440" y="722376"/>
+            <a:ext cx="6629400" cy="201168"/>
+          </a:xfrm>
+          <a:prstGeom prst="rect">
+            <a:avLst/>
+          </a:prstGeom>
+          <a:noFill/>
+          <a:ln/>
+        </p:spPr>
+        <p:txBody>
+          <a:bodyPr wrap="square" lIns="0" tIns="0" rIns="0" bIns="0" rtlCol="0" anchor="ctr">
+            <a:normAutofit/>
+          </a:bodyPr>
+          <a:lstStyle/>
+          <a:p>
+            <a:pPr indent="0" marL="0">
+              <a:buNone/>
+            </a:pPr>
+            <a:r>
+              <a:rPr lang="en-US" sz="900" dirty="0">
+                <a:solidFill>
+                  <a:srgbClr val="5F5F5A"/>
+                </a:solidFill>
+                <a:latin typeface="Arial" pitchFamily="34" charset="0"/>
+                <a:ea typeface="Arial" pitchFamily="34" charset="-122"/>
+                <a:cs typeface="Arial" pitchFamily="34" charset="-120"/>
+              </a:rPr>
+              <a:t>ELDA Lead Leaders, SNCO Promotion Course  ·  Christchurch and Wanaka</a:t>
+            </a:r>
+            <a:endParaRPr lang="en-US" sz="900" dirty="0"/>
+          </a:p>
+        </p:txBody>
+      </p:sp>
+      <p:pic>
+        <p:nvPicPr>
+          <p:cNvPr id="4" name="Image 0" descr="preencoded.png">    </p:cNvPr>
+          <p:cNvPicPr>
+            <a:picLocks noChangeAspect="1"/>
+          </p:cNvPicPr>
+          <p:nvPr/>
+        </p:nvPicPr>
+        <p:blipFill>
+          <a:blip r:embed="rId1"/>
+          <a:stretch>
+            <a:fillRect/>
+          </a:stretch>
+        </p:blipFill>
+        <p:spPr>
+          <a:xfrm>
+            <a:off x="8095415" y="274320"/>
+            <a:ext cx="524403" cy="640080"/>
+          </a:xfrm>
+          <a:prstGeom prst="rect">
+            <a:avLst/>
+          </a:prstGeom>
+        </p:spPr>
+      </p:pic>
+      <p:sp>
+        <p:nvSpPr>
+          <p:cNvPr id="5" name="Text 7"/>
+          <p:cNvSpPr/>
+          <p:nvPr>
+            <p:ph idx="112" type="body" hasCustomPrompt="1"/>
+          </p:nvPr>
+        </p:nvSpPr>
+        <p:spPr>
+          <a:xfrm>
+            <a:off x="320040" y="1353312"/>
+            <a:ext cx="3246120" cy="640080"/>
+          </a:xfrm>
+          <a:prstGeom prst="rect">
+            <a:avLst/>
+          </a:prstGeom>
+          <a:noFill/>
+          <a:ln/>
+        </p:spPr>
+        <p:txBody>
+          <a:bodyPr wrap="square" lIns="0" tIns="0" rIns="0" bIns="0" rtlCol="0" anchor="t">
+            <a:normAutofit/>
+          </a:bodyPr>
+          <a:lstStyle/>
+          <a:p>
+            <a:pPr indent="0" marL="0">
+              <a:spcAft>
+                <a:spcPts val="300"/>
+              </a:spcAft>
+              <a:buNone/>
+            </a:pPr>
+            <a:r>
+              <a:rPr lang="en-US" sz="850" dirty="0">
+                <a:solidFill>
+                  <a:srgbClr val="222222"/>
+                </a:solidFill>
+                <a:latin typeface="Arial" pitchFamily="34" charset="0"/>
+                <a:ea typeface="Arial" pitchFamily="34" charset="-122"/>
+                <a:cs typeface="Arial" pitchFamily="34" charset="-120"/>
+              </a:rPr>
+              <a:t>To enhance leadership and maintain warrior ethos in order to provide world-class, operationally focused leaders, through a challenging rock-climbing activity supported by leadership tools, a Hogan psychometric report, reflection and behaviour selection.</a:t>
+            </a:r>
+            <a:endParaRPr lang="en-US" sz="850" dirty="0"/>
+          </a:p>
+        </p:txBody>
+      </p:sp>
+      <p:sp>
+        <p:nvSpPr>
+          <p:cNvPr id="6" name="Text 9"/>
+          <p:cNvSpPr/>
+          <p:nvPr>
+            <p:ph idx="115" type="body" hasCustomPrompt="1"/>
+          </p:nvPr>
+        </p:nvSpPr>
+        <p:spPr>
+          <a:xfrm>
+            <a:off x="320040" y="2249424"/>
+            <a:ext cx="3246120" cy="1572768"/>
+          </a:xfrm>
+          <a:prstGeom prst="rect">
+            <a:avLst/>
+          </a:prstGeom>
+          <a:noFill/>
+          <a:ln/>
+        </p:spPr>
+        <p:txBody>
+          <a:bodyPr wrap="square" lIns="0" tIns="0" rIns="0" bIns="0" rtlCol="0" anchor="t">
+            <a:normAutofit/>
+          </a:bodyPr>
+          <a:lstStyle/>
+          <a:p>
+            <a:pPr marL="114300" indent="-114300">
+              <a:spcAft>
+                <a:spcPts val="300"/>
+              </a:spcAft>
+              <a:buSzPct val="100000"/>
+              <a:buChar char="•"/>
+            </a:pPr>
+            <a:r>
+              <a:rPr lang="en-US" sz="850" b="1" dirty="0">
+                <a:solidFill>
+                  <a:srgbClr val="222222"/>
+                </a:solidFill>
+                <a:latin typeface="Arial" pitchFamily="34" charset="0"/>
+                <a:ea typeface="Arial" pitchFamily="34" charset="-122"/>
+                <a:cs typeface="Arial" pitchFamily="34" charset="-120"/>
+              </a:rPr>
+              <a:t>30 students completed the ELDA phase of Lead Leaders: 21 from the SNCO Promotion Course and seven junior officers, in syndicates of up to eight across Christchurch and Wanaka.</a:t>
+            </a:r>
+            <a:endParaRPr lang="en-US" sz="850" dirty="0"/>
+          </a:p>
+          <a:p>
+            <a:pPr marL="114300" indent="-114300">
+              <a:spcAft>
+                <a:spcPts val="300"/>
+              </a:spcAft>
+              <a:buSzPct val="100000"/>
+              <a:buChar char="•"/>
+            </a:pPr>
+            <a:r>
+              <a:rPr lang="en-US" sz="850" dirty="0">
+                <a:solidFill>
+                  <a:srgbClr val="222222"/>
+                </a:solidFill>
+                <a:latin typeface="Arial" pitchFamily="34" charset="0"/>
+                <a:ea typeface="Arial" pitchFamily="34" charset="-122"/>
+                <a:cs typeface="Arial" pitchFamily="34" charset="-120"/>
+              </a:rPr>
+              <a:t>Facilitation content combined with rock climbing enabled behaviour-based peer feedback: an accurate snapshot of each student's current behaviour and its impact on others.</a:t>
+            </a:r>
+            <a:endParaRPr lang="en-US" sz="850" dirty="0"/>
+          </a:p>
+          <a:p>
+            <a:pPr marL="114300" indent="-114300">
+              <a:spcAft>
+                <a:spcPts val="300"/>
+              </a:spcAft>
+              <a:buSzPct val="100000"/>
+              <a:buChar char="•"/>
+            </a:pPr>
+            <a:r>
+              <a:rPr lang="en-US" sz="850" dirty="0">
+                <a:solidFill>
+                  <a:srgbClr val="222222"/>
+                </a:solidFill>
+                <a:latin typeface="Arial" pitchFamily="34" charset="0"/>
+                <a:ea typeface="Arial" pitchFamily="34" charset="-122"/>
+                <a:cs typeface="Arial" pitchFamily="34" charset="-120"/>
+              </a:rPr>
+              <a:t>Peer-endorsed strategies gave every student a practical plan to lift intrapersonal and interpersonal effectiveness under the Domain Model.</a:t>
+            </a:r>
+            <a:endParaRPr lang="en-US" sz="850" dirty="0"/>
+          </a:p>
+        </p:txBody>
+      </p:sp>
+      <p:sp>
+        <p:nvSpPr>
+          <p:cNvPr id="7" name="Text 11"/>
+          <p:cNvSpPr/>
+          <p:nvPr>
+            <p:ph idx="118" type="body" hasCustomPrompt="1"/>
+          </p:nvPr>
+        </p:nvSpPr>
+        <p:spPr>
+          <a:xfrm>
+            <a:off x="320040" y="4078224"/>
+            <a:ext cx="3246120" cy="566928"/>
+          </a:xfrm>
+          <a:prstGeom prst="rect">
+            <a:avLst/>
+          </a:prstGeom>
+          <a:noFill/>
+          <a:ln/>
+        </p:spPr>
+        <p:txBody>
+          <a:bodyPr wrap="square" lIns="0" tIns="0" rIns="0" bIns="0" rtlCol="0" anchor="t">
+            <a:normAutofit/>
+          </a:bodyPr>
+          <a:lstStyle/>
+          <a:p>
+            <a:pPr indent="0" marL="0">
+              <a:spcAft>
+                <a:spcPts val="300"/>
+              </a:spcAft>
+              <a:buNone/>
+            </a:pPr>
+            <a:r>
+              <a:rPr lang="en-US" sz="850" i="1" dirty="0">
+                <a:solidFill>
+                  <a:srgbClr val="002516"/>
+                </a:solidFill>
+                <a:latin typeface="Arial" pitchFamily="34" charset="0"/>
+                <a:ea typeface="Arial" pitchFamily="34" charset="-122"/>
+                <a:cs typeface="Arial" pitchFamily="34" charset="-120"/>
+              </a:rPr>
+              <a:t>Student evaluations indicate the course was well conducted, with students extremely pleased with the facilitation content and its delivery by instructors. </a:t>
+            </a:r>
+            <a:pPr indent="0" marL="0">
+              <a:spcAft>
+                <a:spcPts val="300"/>
+              </a:spcAft>
+              <a:buNone/>
+            </a:pPr>
+            <a:r>
+              <a:rPr lang="en-US" sz="850" i="1" dirty="0">
+                <a:solidFill>
+                  <a:srgbClr val="5F5F5A"/>
+                </a:solidFill>
+                <a:latin typeface="Arial" pitchFamily="34" charset="0"/>
+                <a:ea typeface="Arial" pitchFamily="34" charset="-122"/>
+                <a:cs typeface="Arial" pitchFamily="34" charset="-120"/>
+              </a:rPr>
+              <a:t>Student evaluation summary</a:t>
+            </a:r>
+            <a:endParaRPr lang="en-US" sz="850" dirty="0"/>
+          </a:p>
+        </p:txBody>
+      </p:sp>
+      <p:pic>
+        <p:nvPicPr>
+          <p:cNvPr id="8" name="Image 1" descr="preencoded.png">    </p:cNvPr>
+          <p:cNvPicPr>
+            <a:picLocks noChangeAspect="1"/>
+          </p:cNvPicPr>
+          <p:nvPr/>
+        </p:nvPicPr>
+        <p:blipFill>
+          <a:blip r:embed="rId2"/>
+          <a:stretch>
+            <a:fillRect/>
+          </a:stretch>
+        </p:blipFill>
+        <p:spPr>
+          <a:xfrm>
+            <a:off x="3794760" y="1188720"/>
+            <a:ext cx="2468880" cy="1440180"/>
+          </a:xfrm>
+          <a:prstGeom prst="rect">
+            <a:avLst/>
+          </a:prstGeom>
+        </p:spPr>
+      </p:pic>
+      <p:pic>
+        <p:nvPicPr>
+          <p:cNvPr id="9" name="Image 2" descr="preencoded.png">    </p:cNvPr>
+          <p:cNvPicPr>
+            <a:picLocks noChangeAspect="1"/>
+          </p:cNvPicPr>
+          <p:nvPr/>
+        </p:nvPicPr>
+        <p:blipFill>
+          <a:blip r:embed="rId3"/>
+          <a:stretch>
+            <a:fillRect/>
+          </a:stretch>
+        </p:blipFill>
+        <p:spPr>
+          <a:xfrm>
+            <a:off x="6355080" y="1188720"/>
+            <a:ext cx="2468880" cy="1440180"/>
+          </a:xfrm>
+          <a:prstGeom prst="rect">
+            <a:avLst/>
+          </a:prstGeom>
+        </p:spPr>
+      </p:pic>
+      <p:pic>
+        <p:nvPicPr>
+          <p:cNvPr id="10" name="Image 3" descr="preencoded.png">    </p:cNvPr>
+          <p:cNvPicPr>
+            <a:picLocks noChangeAspect="1"/>
+          </p:cNvPicPr>
+          <p:nvPr/>
+        </p:nvPicPr>
+        <p:blipFill>
+          <a:blip r:embed="rId4"/>
+          <a:stretch>
+            <a:fillRect/>
+          </a:stretch>
+        </p:blipFill>
+        <p:spPr>
+          <a:xfrm>
+            <a:off x="3794760" y="2720340"/>
+            <a:ext cx="2468880" cy="1440180"/>
+          </a:xfrm>
+          <a:prstGeom prst="rect">
+            <a:avLst/>
+          </a:prstGeom>
+        </p:spPr>
+      </p:pic>
+      <p:pic>
+        <p:nvPicPr>
+          <p:cNvPr id="11" name="Image 4" descr="preencoded.png">    </p:cNvPr>
+          <p:cNvPicPr>
+            <a:picLocks noChangeAspect="1"/>
+          </p:cNvPicPr>
+          <p:nvPr/>
+        </p:nvPicPr>
+        <p:blipFill>
+          <a:blip r:embed="rId5"/>
+          <a:stretch>
+            <a:fillRect/>
+          </a:stretch>
+        </p:blipFill>
+        <p:spPr>
+          <a:xfrm>
+            <a:off x="6355080" y="2720340"/>
+            <a:ext cx="2468880" cy="1440180"/>
+          </a:xfrm>
+          <a:prstGeom prst="rect">
+            <a:avLst/>
+          </a:prstGeom>
+        </p:spPr>
+      </p:pic>
+      <p:sp>
+        <p:nvSpPr>
+          <p:cNvPr id="12" name="Shape 5"/>
+          <p:cNvSpPr/>
+          <p:nvPr/>
+        </p:nvSpPr>
+        <p:spPr>
+          <a:xfrm>
+            <a:off x="3877056" y="1271016"/>
+            <a:ext cx="237744" cy="237744"/>
+          </a:xfrm>
+          <a:prstGeom prst="ellipse">
+            <a:avLst/>
+          </a:prstGeom>
+          <a:solidFill>
+            <a:srgbClr val="000000"/>
+          </a:solidFill>
+          <a:ln w="12700">
+            <a:solidFill>
+              <a:srgbClr val="000000"/>
+            </a:solidFill>
+            <a:prstDash val="solid"/>
+          </a:ln>
+        </p:spPr>
+      </p:sp>
+      <p:sp>
+        <p:nvSpPr>
+          <p:cNvPr id="13" name="Text 6"/>
+          <p:cNvSpPr txBox="1"/>
+          <p:nvPr/>
+        </p:nvSpPr>
+        <p:spPr>
+          <a:xfrm>
+            <a:off x="3877056" y="1271016"/>
+            <a:ext cx="237744" cy="237744"/>
+          </a:xfrm>
+          <a:prstGeom prst="rect">
+            <a:avLst/>
+          </a:prstGeom>
+          <a:noFill/>
+          <a:ln/>
+        </p:spPr>
+        <p:txBody>
+          <a:bodyPr wrap="square" lIns="0" tIns="0" rIns="0" bIns="0" rtlCol="0" anchor="ctr"/>
+          <a:lstStyle/>
+          <a:p>
+            <a:pPr algn="ctr" indent="0" marL="0">
+              <a:buNone/>
+            </a:pPr>
+            <a:r>
+              <a:rPr lang="en-US" sz="800" b="1" dirty="0">
+                <a:solidFill>
+                  <a:srgbClr val="FFFFFF"/>
+                </a:solidFill>
+                <a:latin typeface="Arial" pitchFamily="34" charset="0"/>
+                <a:ea typeface="Arial" pitchFamily="34" charset="-122"/>
+                <a:cs typeface="Arial" pitchFamily="34" charset="-120"/>
+              </a:rPr>
+              <a:t>1</a:t>
+            </a:r>
+            <a:endParaRPr lang="en-US" sz="800" dirty="0"/>
+          </a:p>
+        </p:txBody>
+      </p:sp>
+      <p:sp>
+        <p:nvSpPr>
+          <p:cNvPr id="14" name="Shape 7"/>
+          <p:cNvSpPr/>
+          <p:nvPr/>
+        </p:nvSpPr>
+        <p:spPr>
+          <a:xfrm>
+            <a:off x="6437376" y="1271016"/>
+            <a:ext cx="237744" cy="237744"/>
+          </a:xfrm>
+          <a:prstGeom prst="ellipse">
+            <a:avLst/>
+          </a:prstGeom>
+          <a:solidFill>
+            <a:srgbClr val="000000"/>
+          </a:solidFill>
+          <a:ln w="12700">
+            <a:solidFill>
+              <a:srgbClr val="000000"/>
+            </a:solidFill>
+            <a:prstDash val="solid"/>
+          </a:ln>
+        </p:spPr>
+      </p:sp>
+      <p:sp>
+        <p:nvSpPr>
+          <p:cNvPr id="15" name="Text 8"/>
+          <p:cNvSpPr txBox="1"/>
+          <p:nvPr/>
+        </p:nvSpPr>
+        <p:spPr>
+          <a:xfrm>
+            <a:off x="6437376" y="1271016"/>
+            <a:ext cx="237744" cy="237744"/>
+          </a:xfrm>
+          <a:prstGeom prst="rect">
+            <a:avLst/>
+          </a:prstGeom>
+          <a:noFill/>
+          <a:ln/>
+        </p:spPr>
+        <p:txBody>
+          <a:bodyPr wrap="square" lIns="0" tIns="0" rIns="0" bIns="0" rtlCol="0" anchor="ctr"/>
+          <a:lstStyle/>
+          <a:p>
+            <a:pPr algn="ctr" indent="0" marL="0">
+              <a:buNone/>
+            </a:pPr>
+            <a:r>
+              <a:rPr lang="en-US" sz="800" b="1" dirty="0">
+                <a:solidFill>
+                  <a:srgbClr val="FFFFFF"/>
+                </a:solidFill>
+                <a:latin typeface="Arial" pitchFamily="34" charset="0"/>
+                <a:ea typeface="Arial" pitchFamily="34" charset="-122"/>
+                <a:cs typeface="Arial" pitchFamily="34" charset="-120"/>
+              </a:rPr>
+              <a:t>2</a:t>
+            </a:r>
+            <a:endParaRPr lang="en-US" sz="800" dirty="0"/>
+          </a:p>
+        </p:txBody>
+      </p:sp>
+      <p:sp>
+        <p:nvSpPr>
+          <p:cNvPr id="16" name="Shape 9"/>
+          <p:cNvSpPr/>
+          <p:nvPr/>
+        </p:nvSpPr>
+        <p:spPr>
+          <a:xfrm>
+            <a:off x="3877056" y="2802636"/>
+            <a:ext cx="237744" cy="237744"/>
+          </a:xfrm>
+          <a:prstGeom prst="ellipse">
+            <a:avLst/>
+          </a:prstGeom>
+          <a:solidFill>
+            <a:srgbClr val="000000"/>
+          </a:solidFill>
+          <a:ln w="12700">
+            <a:solidFill>
+              <a:srgbClr val="000000"/>
+            </a:solidFill>
+            <a:prstDash val="solid"/>
+          </a:ln>
+        </p:spPr>
+      </p:sp>
+      <p:sp>
+        <p:nvSpPr>
+          <p:cNvPr id="17" name="Text 10"/>
+          <p:cNvSpPr txBox="1"/>
+          <p:nvPr/>
+        </p:nvSpPr>
+        <p:spPr>
+          <a:xfrm>
+            <a:off x="3877056" y="2802636"/>
+            <a:ext cx="237744" cy="237744"/>
+          </a:xfrm>
+          <a:prstGeom prst="rect">
+            <a:avLst/>
+          </a:prstGeom>
+          <a:noFill/>
+          <a:ln/>
+        </p:spPr>
+        <p:txBody>
+          <a:bodyPr wrap="square" lIns="0" tIns="0" rIns="0" bIns="0" rtlCol="0" anchor="ctr"/>
+          <a:lstStyle/>
+          <a:p>
+            <a:pPr algn="ctr" indent="0" marL="0">
+              <a:buNone/>
+            </a:pPr>
+            <a:r>
+              <a:rPr lang="en-US" sz="800" b="1" dirty="0">
+                <a:solidFill>
+                  <a:srgbClr val="FFFFFF"/>
+                </a:solidFill>
+                <a:latin typeface="Arial" pitchFamily="34" charset="0"/>
+                <a:ea typeface="Arial" pitchFamily="34" charset="-122"/>
+                <a:cs typeface="Arial" pitchFamily="34" charset="-120"/>
+              </a:rPr>
+              <a:t>3</a:t>
+            </a:r>
+            <a:endParaRPr lang="en-US" sz="800" dirty="0"/>
+          </a:p>
+        </p:txBody>
+      </p:sp>
+      <p:sp>
+        <p:nvSpPr>
+          <p:cNvPr id="18" name="Shape 11"/>
+          <p:cNvSpPr/>
+          <p:nvPr/>
+        </p:nvSpPr>
+        <p:spPr>
+          <a:xfrm>
+            <a:off x="6437376" y="2802636"/>
+            <a:ext cx="237744" cy="237744"/>
+          </a:xfrm>
+          <a:prstGeom prst="ellipse">
+            <a:avLst/>
+          </a:prstGeom>
+          <a:solidFill>
+            <a:srgbClr val="000000"/>
+          </a:solidFill>
+          <a:ln w="12700">
+            <a:solidFill>
+              <a:srgbClr val="000000"/>
+            </a:solidFill>
+            <a:prstDash val="solid"/>
+          </a:ln>
+        </p:spPr>
+      </p:sp>
+      <p:sp>
+        <p:nvSpPr>
+          <p:cNvPr id="19" name="Text 12"/>
+          <p:cNvSpPr txBox="1"/>
+          <p:nvPr/>
+        </p:nvSpPr>
+        <p:spPr>
+          <a:xfrm>
+            <a:off x="6437376" y="2802636"/>
+            <a:ext cx="237744" cy="237744"/>
+          </a:xfrm>
+          <a:prstGeom prst="rect">
+            <a:avLst/>
+          </a:prstGeom>
+          <a:noFill/>
+          <a:ln/>
+        </p:spPr>
+        <p:txBody>
+          <a:bodyPr wrap="square" lIns="0" tIns="0" rIns="0" bIns="0" rtlCol="0" anchor="ctr"/>
+          <a:lstStyle/>
+          <a:p>
+            <a:pPr algn="ctr" indent="0" marL="0">
+              <a:buNone/>
+            </a:pPr>
+            <a:r>
+              <a:rPr lang="en-US" sz="800" b="1" dirty="0">
+                <a:solidFill>
+                  <a:srgbClr val="FFFFFF"/>
+                </a:solidFill>
+                <a:latin typeface="Arial" pitchFamily="34" charset="0"/>
+                <a:ea typeface="Arial" pitchFamily="34" charset="-122"/>
+                <a:cs typeface="Arial" pitchFamily="34" charset="-120"/>
+              </a:rPr>
+              <a:t>4</a:t>
+            </a:r>
+            <a:endParaRPr lang="en-US" sz="800" dirty="0"/>
+          </a:p>
+        </p:txBody>
+      </p:sp>
+      <p:sp>
+        <p:nvSpPr>
+          <p:cNvPr id="20" name="Text 11"/>
+          <p:cNvSpPr/>
+          <p:nvPr>
+            <p:ph idx="123" type="body" hasCustomPrompt="1"/>
+          </p:nvPr>
+        </p:nvSpPr>
+        <p:spPr>
+          <a:xfrm>
+            <a:off x="3794760" y="4251960"/>
+            <a:ext cx="5029200" cy="384048"/>
+          </a:xfrm>
+          <a:prstGeom prst="rect">
+            <a:avLst/>
+          </a:prstGeom>
+          <a:noFill/>
+          <a:ln/>
+        </p:spPr>
+        <p:txBody>
+          <a:bodyPr wrap="square" lIns="0" tIns="0" rIns="0" bIns="0" rtlCol="0" anchor="t">
+            <a:normAutofit/>
+          </a:bodyPr>
+          <a:lstStyle/>
+          <a:p>
+            <a:pPr indent="0" marL="0">
+              <a:buNone/>
+            </a:pPr>
+            <a:r>
+              <a:rPr lang="en-US" sz="750" b="1" dirty="0">
+                <a:solidFill>
+                  <a:srgbClr val="000000"/>
+                </a:solidFill>
+                <a:latin typeface="Arial" pitchFamily="34" charset="0"/>
+                <a:ea typeface="Arial" pitchFamily="34" charset="-122"/>
+                <a:cs typeface="Arial" pitchFamily="34" charset="-120"/>
+              </a:rPr>
+              <a:t>1  </a:t>
+            </a:r>
+            <a:pPr indent="0" marL="0">
+              <a:buNone/>
+            </a:pPr>
+            <a:r>
+              <a:rPr lang="en-US" sz="750" dirty="0">
+                <a:solidFill>
+                  <a:srgbClr val="5F5F5A"/>
+                </a:solidFill>
+                <a:latin typeface="Arial" pitchFamily="34" charset="0"/>
+                <a:ea typeface="Arial" pitchFamily="34" charset="-122"/>
+                <a:cs typeface="Arial" pitchFamily="34" charset="-120"/>
+              </a:rPr>
+              <a:t>Lead climb on the main face   ·   </a:t>
+            </a:r>
+            <a:pPr indent="0" marL="0">
+              <a:buNone/>
+            </a:pPr>
+            <a:r>
+              <a:rPr lang="en-US" sz="750" b="1" dirty="0">
+                <a:solidFill>
+                  <a:srgbClr val="000000"/>
+                </a:solidFill>
+                <a:latin typeface="Arial" pitchFamily="34" charset="0"/>
+                <a:ea typeface="Arial" pitchFamily="34" charset="-122"/>
+                <a:cs typeface="Arial" pitchFamily="34" charset="-120"/>
+              </a:rPr>
+              <a:t>2  </a:t>
+            </a:r>
+            <a:pPr indent="0" marL="0">
+              <a:buNone/>
+            </a:pPr>
+            <a:r>
+              <a:rPr lang="en-US" sz="750" dirty="0">
+                <a:solidFill>
+                  <a:srgbClr val="5F5F5A"/>
+                </a:solidFill>
+                <a:latin typeface="Arial" pitchFamily="34" charset="0"/>
+                <a:ea typeface="Arial" pitchFamily="34" charset="-122"/>
+                <a:cs typeface="Arial" pitchFamily="34" charset="-120"/>
+              </a:rPr>
+              <a:t>Top-rope pitch, Wanaka   ·   </a:t>
+            </a:r>
+            <a:pPr indent="0" marL="0">
+              <a:buNone/>
+            </a:pPr>
+            <a:r>
+              <a:rPr lang="en-US" sz="750" b="1" dirty="0">
+                <a:solidFill>
+                  <a:srgbClr val="000000"/>
+                </a:solidFill>
+                <a:latin typeface="Arial" pitchFamily="34" charset="0"/>
+                <a:ea typeface="Arial" pitchFamily="34" charset="-122"/>
+                <a:cs typeface="Arial" pitchFamily="34" charset="-120"/>
+              </a:rPr>
+              <a:t>3  </a:t>
+            </a:r>
+            <a:pPr indent="0" marL="0">
+              <a:buNone/>
+            </a:pPr>
+            <a:r>
+              <a:rPr lang="en-US" sz="750" dirty="0">
+                <a:solidFill>
+                  <a:srgbClr val="5F5F5A"/>
+                </a:solidFill>
+                <a:latin typeface="Arial" pitchFamily="34" charset="0"/>
+                <a:ea typeface="Arial" pitchFamily="34" charset="-122"/>
+                <a:cs typeface="Arial" pitchFamily="34" charset="-120"/>
+              </a:rPr>
+              <a:t>Syndicate on the summit block   ·   </a:t>
+            </a:r>
+            <a:pPr indent="0" marL="0">
+              <a:buNone/>
+            </a:pPr>
+            <a:r>
+              <a:rPr lang="en-US" sz="750" b="1" dirty="0">
+                <a:solidFill>
+                  <a:srgbClr val="000000"/>
+                </a:solidFill>
+                <a:latin typeface="Arial" pitchFamily="34" charset="0"/>
+                <a:ea typeface="Arial" pitchFamily="34" charset="-122"/>
+                <a:cs typeface="Arial" pitchFamily="34" charset="-120"/>
+              </a:rPr>
+              <a:t>4  </a:t>
+            </a:r>
+            <a:pPr indent="0" marL="0">
+              <a:buNone/>
+            </a:pPr>
+            <a:r>
+              <a:rPr lang="en-US" sz="750" dirty="0">
+                <a:solidFill>
+                  <a:srgbClr val="5F5F5A"/>
+                </a:solidFill>
+                <a:latin typeface="Arial" pitchFamily="34" charset="0"/>
+                <a:ea typeface="Arial" pitchFamily="34" charset="-122"/>
+                <a:cs typeface="Arial" pitchFamily="34" charset="-120"/>
+              </a:rPr>
+              <a:t>Abseil descent</a:t>
+            </a:r>
+            <a:endParaRPr lang="en-US" sz="750" dirty="0"/>
+          </a:p>
+        </p:txBody>
+      </p:sp>
+      <p:sp>
+        <p:nvSpPr>
+          <p:cNvPr id="21" name="Text 14"/>
+          <p:cNvSpPr txBox="1"/>
+          <p:nvPr/>
+        </p:nvSpPr>
+        <p:spPr>
+          <a:xfrm>
+            <a:off x="1188720" y="4782312"/>
+            <a:ext cx="731520" cy="219456"/>
+          </a:xfrm>
+          <a:prstGeom prst="rect">
+            <a:avLst>
+              <a:gd name="adj" fmla="val 50000"/>
+            </a:avLst>
+          </a:prstGeom>
+          <a:noFill/>
+          <a:ln w="9525">
+            <a:solidFill>
+              <a:srgbClr val="A89662"/>
+            </a:solidFill>
+          </a:ln>
+        </p:spPr>
+        <p:txBody>
+          <a:bodyPr wrap="square" lIns="0" tIns="0" rIns="0" bIns="0" rtlCol="0" anchor="ctr"/>
+          <a:lstStyle/>
+          <a:p>
+            <a:pPr algn="ctr" indent="0" marL="0">
+              <a:buNone/>
+            </a:pPr>
+            <a:r>
+              <a:rPr lang="en-US" sz="700" b="1" spc="200" kern="0" dirty="0">
+                <a:solidFill>
+                  <a:srgbClr val="A89662"/>
+                </a:solidFill>
+                <a:latin typeface="Arial" pitchFamily="34" charset="0"/>
+                <a:ea typeface="Arial" pitchFamily="34" charset="-122"/>
+                <a:cs typeface="Arial" pitchFamily="34" charset="-120"/>
+              </a:rPr>
+              <a:t>EXAMPLE</a:t>
+            </a:r>
+            <a:endParaRPr lang="en-US" sz="700" dirty="0"/>
+          </a:p>
+        </p:txBody>
+      </p:sp>
+      <p:sp>
+        <p:nvSpPr>
+          <p:cNvPr id="23" name="Text 3"/>
+          <p:cNvSpPr/>
+          <p:nvPr>
+            <p:ph idx="106" hasCustomPrompt="1"/>
+          </p:nvPr>
+        </p:nvSpPr>
+        <p:spPr>
+          <a:xfrm>
+            <a:off x="8037576" y="274320"/>
+            <a:ext cx="640080" cy="640080"/>
+          </a:xfrm>
+          <a:prstGeom prst="rect">
+            <a:avLst/>
+          </a:prstGeom>
+          <a:noFill/>
+          <a:ln/>
+        </p:spPr>
+        <p:txBody>
+          <a:bodyPr wrap="square" rtlCol="0">
+            <a:normAutofit/>
+          </a:bodyPr>
+          <a:lstStyle/>
+          <a:p>
+            <a:pPr indent="0" marL="0">
+              <a:buNone/>
+            </a:pPr>
+            <a:endParaRPr lang="en-US" dirty="0"/>
+          </a:p>
+        </p:txBody>
+      </p:sp>
+      <p:sp>
+        <p:nvSpPr>
+          <p:cNvPr id="24" name="Text 11"/>
+          <p:cNvSpPr/>
+          <p:nvPr>
+            <p:ph idx="119" hasCustomPrompt="1"/>
+          </p:nvPr>
+        </p:nvSpPr>
+        <p:spPr>
+          <a:xfrm>
+            <a:off x="3794760" y="1188720"/>
+            <a:ext cx="2468880" cy="1440180"/>
+          </a:xfrm>
+          <a:prstGeom prst="rect">
+            <a:avLst/>
+          </a:prstGeom>
+          <a:noFill/>
+          <a:ln/>
+        </p:spPr>
+        <p:txBody>
+          <a:bodyPr wrap="square" rtlCol="0">
+            <a:normAutofit/>
+          </a:bodyPr>
+          <a:lstStyle/>
+          <a:p>
+            <a:pPr indent="0" marL="0">
+              <a:buNone/>
+            </a:pPr>
+            <a:endParaRPr lang="en-US" dirty="0"/>
+          </a:p>
+        </p:txBody>
+      </p:sp>
+      <p:sp>
+        <p:nvSpPr>
+          <p:cNvPr id="25" name="Text 11"/>
+          <p:cNvSpPr/>
+          <p:nvPr>
+            <p:ph idx="120" hasCustomPrompt="1"/>
+          </p:nvPr>
+        </p:nvSpPr>
+        <p:spPr>
+          <a:xfrm>
+            <a:off x="6355080" y="1188720"/>
+            <a:ext cx="2468880" cy="1440180"/>
+          </a:xfrm>
+          <a:prstGeom prst="rect">
+            <a:avLst/>
+          </a:prstGeom>
+          <a:noFill/>
+          <a:ln/>
+        </p:spPr>
+        <p:txBody>
+          <a:bodyPr wrap="square" rtlCol="0">
+            <a:normAutofit/>
+          </a:bodyPr>
+          <a:lstStyle/>
+          <a:p>
+            <a:pPr indent="0" marL="0">
+              <a:buNone/>
+            </a:pPr>
+            <a:endParaRPr lang="en-US" dirty="0"/>
+          </a:p>
+        </p:txBody>
+      </p:sp>
+      <p:sp>
+        <p:nvSpPr>
+          <p:cNvPr id="26" name="Text 11"/>
+          <p:cNvSpPr/>
+          <p:nvPr>
+            <p:ph idx="121" hasCustomPrompt="1"/>
+          </p:nvPr>
+        </p:nvSpPr>
+        <p:spPr>
+          <a:xfrm>
+            <a:off x="3794760" y="2720340"/>
+            <a:ext cx="2468880" cy="1440180"/>
+          </a:xfrm>
+          <a:prstGeom prst="rect">
+            <a:avLst/>
+          </a:prstGeom>
+          <a:noFill/>
+          <a:ln/>
+        </p:spPr>
+        <p:txBody>
+          <a:bodyPr wrap="square" rtlCol="0">
+            <a:normAutofit/>
+          </a:bodyPr>
+          <a:lstStyle/>
+          <a:p>
+            <a:pPr indent="0" marL="0">
+              <a:buNone/>
+            </a:pPr>
+            <a:endParaRPr lang="en-US" dirty="0"/>
+          </a:p>
+        </p:txBody>
+      </p:sp>
+      <p:sp>
+        <p:nvSpPr>
+          <p:cNvPr id="27" name="Text 11"/>
+          <p:cNvSpPr/>
+          <p:nvPr>
+            <p:ph idx="122" hasCustomPrompt="1"/>
+          </p:nvPr>
+        </p:nvSpPr>
+        <p:spPr>
+          <a:xfrm>
+            <a:off x="6355080" y="2720340"/>
+            <a:ext cx="2468880" cy="1440180"/>
+          </a:xfrm>
+          <a:prstGeom prst="rect">
+            <a:avLst/>
+          </a:prstGeom>
+          <a:noFill/>
+          <a:ln/>
+        </p:spPr>
+        <p:txBody>
+          <a:bodyPr wrap="square" rtlCol="0">
+            <a:normAutofit/>
+          </a:bodyPr>
+          <a:lstStyle/>
+          <a:p>
+            <a:pPr indent="0" marL="0">
+              <a:buNone/>
+            </a:pPr>
+            <a:endParaRPr lang="en-US" dirty="0"/>
+          </a:p>
+        </p:txBody>
+      </p:sp>
+    </p:spTree>
+  </p:cSld>
+  <p:clrMapOvr>
+    <a:masterClrMapping/>
+  </p:clrMapOvr>
+</p:sld>
+</file>
+
+<file path=ppt/slides/slide3.xml><?xml version="1.0" encoding="utf-8"?>
+<p:sld xmlns:a="http://schemas.openxmlformats.org/drawingml/2006/main" xmlns:r="http://schemas.openxmlformats.org/officeDocument/2006/relationships" xmlns:p="http://schemas.openxmlformats.org/presentationml/2006/main">
+  <p:cSld name="Slide 3">
+    <p:spTree>
+      <p:nvGrpSpPr>
+        <p:cNvPr id="1" name=""/>
+        <p:cNvGrpSpPr/>
+        <p:nvPr/>
+      </p:nvGrpSpPr>
+      <p:grpSpPr>
+        <a:xfrm>
+          <a:off x="0" y="0"/>
+          <a:ext cx="0" cy="0"/>
+          <a:chOff x="0" y="0"/>
+          <a:chExt cx="0" cy="0"/>
+        </a:xfrm>
+      </p:grpSpPr>
+      <p:sp>
+        <p:nvSpPr>
           <p:cNvPr id="2" name="Text 0"/>
           <p:cNvSpPr txBox="1"/>
           <p:nvPr/>
@@ -5159,7 +6279,7 @@
 </p:sld>
 </file>
 
-<file path=ppt/slides/slide3.xml><?xml version="1.0" encoding="utf-8"?>
+<file path=ppt/slides/slide4.xml><?xml version="1.0" encoding="utf-8"?>
 <p:sld xmlns:a="http://schemas.openxmlformats.org/drawingml/2006/main" xmlns:p="http://schemas.openxmlformats.org/presentationml/2006/main" xmlns:r="http://schemas.openxmlformats.org/officeDocument/2006/relationships">
   <p:cSld>
     <p:spTree>

</xml_diff>

<commit_message>
ATG storyboard: size the picture placeholder prompts
PowerPoint rendered the photo and badge prompts at the master body size,
spilling out of the badge slot. Prompts now set at 8pt and 6pt, grey,
centred.

Co-Authored-By: Claude Fable 5.1 <noreply@anthropic.com>
Claude-Session: https://claude.ai/code/session_01LgFPs3fMSncBgbYQ3PfA3o
</commit_message>
<xml_diff>
--- a/output/atg-storyboard-template.pptx
+++ b/output/atg-storyboard-template.pptx
@@ -1038,24 +1038,34 @@
         <p:txBody>
           <a:bodyPr wrap="square" rtlCol="0"/>
           <a:lstStyle>
-            <a:lvl1pPr indent="0" marL="0">
-              <a:buNone/>
-              <a:defRPr lang="en-US" dirty="0"/>
+            <a:lvl1pPr algn="ctr" indent="0" marL="0">
+              <a:buNone/>
+              <a:defRPr lang="en-US" sz="600" dirty="0">
+                <a:solidFill>
+                  <a:srgbClr val="8A8A8A"/>
+                </a:solidFill>
+                <a:latin typeface="Arial" pitchFamily="34" charset="0"/>
+                <a:ea typeface="Arial" pitchFamily="34" charset="-122"/>
+                <a:cs typeface="Arial" pitchFamily="34" charset="-120"/>
+              </a:defRPr>
             </a:lvl1pPr>
           </a:lstStyle>
           <a:p>
-            <a:pPr indent="0" marL="0">
-              <a:buNone/>
-            </a:pPr>
-            <a:r>
-              <a:rPr lang="en-US" dirty="0">
-                <a:solidFill>
-                  <a:srgbClr val="000000"/>
-                </a:solidFill>
-              </a:rPr>
-              <a:t>Unit badge</a:t>
-            </a:r>
-            <a:endParaRPr lang="en-US" dirty="0"/>
+            <a:pPr algn="ctr" indent="0" marL="0">
+              <a:buNone/>
+            </a:pPr>
+            <a:r>
+              <a:rPr lang="en-US" sz="600" dirty="0">
+                <a:solidFill>
+                  <a:srgbClr val="8A8A8A"/>
+                </a:solidFill>
+                <a:latin typeface="Arial" pitchFamily="34" charset="0"/>
+                <a:ea typeface="Arial" pitchFamily="34" charset="-122"/>
+                <a:cs typeface="Arial" pitchFamily="34" charset="-120"/>
+              </a:rPr>
+              <a:t>Badge</a:t>
+            </a:r>
+            <a:endParaRPr lang="en-US" sz="600" dirty="0"/>
           </a:p>
         </p:txBody>
       </p:sp>
@@ -1600,24 +1610,34 @@
         <p:txBody>
           <a:bodyPr wrap="square" rtlCol="0"/>
           <a:lstStyle>
-            <a:lvl1pPr indent="0" marL="0">
-              <a:buNone/>
-              <a:defRPr lang="en-US" dirty="0"/>
+            <a:lvl1pPr algn="ctr" indent="0" marL="0">
+              <a:buNone/>
+              <a:defRPr lang="en-US" sz="800" dirty="0">
+                <a:solidFill>
+                  <a:srgbClr val="8A8A8A"/>
+                </a:solidFill>
+                <a:latin typeface="Arial" pitchFamily="34" charset="0"/>
+                <a:ea typeface="Arial" pitchFamily="34" charset="-122"/>
+                <a:cs typeface="Arial" pitchFamily="34" charset="-120"/>
+              </a:defRPr>
             </a:lvl1pPr>
           </a:lstStyle>
           <a:p>
-            <a:pPr indent="0" marL="0">
-              <a:buNone/>
-            </a:pPr>
-            <a:r>
-              <a:rPr lang="en-US" dirty="0">
-                <a:solidFill>
-                  <a:srgbClr val="000000"/>
-                </a:solidFill>
+            <a:pPr algn="ctr" indent="0" marL="0">
+              <a:buNone/>
+            </a:pPr>
+            <a:r>
+              <a:rPr lang="en-US" sz="800" dirty="0">
+                <a:solidFill>
+                  <a:srgbClr val="8A8A8A"/>
+                </a:solidFill>
+                <a:latin typeface="Arial" pitchFamily="34" charset="0"/>
+                <a:ea typeface="Arial" pitchFamily="34" charset="-122"/>
+                <a:cs typeface="Arial" pitchFamily="34" charset="-120"/>
               </a:rPr>
               <a:t>Photo 1</a:t>
             </a:r>
-            <a:endParaRPr lang="en-US" dirty="0"/>
+            <a:endParaRPr lang="en-US" sz="800" dirty="0"/>
           </a:p>
         </p:txBody>
       </p:sp>
@@ -1643,24 +1663,34 @@
         <p:txBody>
           <a:bodyPr wrap="square" rtlCol="0"/>
           <a:lstStyle>
-            <a:lvl1pPr indent="0" marL="0">
-              <a:buNone/>
-              <a:defRPr lang="en-US" dirty="0"/>
+            <a:lvl1pPr algn="ctr" indent="0" marL="0">
+              <a:buNone/>
+              <a:defRPr lang="en-US" sz="800" dirty="0">
+                <a:solidFill>
+                  <a:srgbClr val="8A8A8A"/>
+                </a:solidFill>
+                <a:latin typeface="Arial" pitchFamily="34" charset="0"/>
+                <a:ea typeface="Arial" pitchFamily="34" charset="-122"/>
+                <a:cs typeface="Arial" pitchFamily="34" charset="-120"/>
+              </a:defRPr>
             </a:lvl1pPr>
           </a:lstStyle>
           <a:p>
-            <a:pPr indent="0" marL="0">
-              <a:buNone/>
-            </a:pPr>
-            <a:r>
-              <a:rPr lang="en-US" dirty="0">
-                <a:solidFill>
-                  <a:srgbClr val="000000"/>
-                </a:solidFill>
+            <a:pPr algn="ctr" indent="0" marL="0">
+              <a:buNone/>
+            </a:pPr>
+            <a:r>
+              <a:rPr lang="en-US" sz="800" dirty="0">
+                <a:solidFill>
+                  <a:srgbClr val="8A8A8A"/>
+                </a:solidFill>
+                <a:latin typeface="Arial" pitchFamily="34" charset="0"/>
+                <a:ea typeface="Arial" pitchFamily="34" charset="-122"/>
+                <a:cs typeface="Arial" pitchFamily="34" charset="-120"/>
               </a:rPr>
               <a:t>Photo 2</a:t>
             </a:r>
-            <a:endParaRPr lang="en-US" dirty="0"/>
+            <a:endParaRPr lang="en-US" sz="800" dirty="0"/>
           </a:p>
         </p:txBody>
       </p:sp>
@@ -1686,24 +1716,34 @@
         <p:txBody>
           <a:bodyPr wrap="square" rtlCol="0"/>
           <a:lstStyle>
-            <a:lvl1pPr indent="0" marL="0">
-              <a:buNone/>
-              <a:defRPr lang="en-US" dirty="0"/>
+            <a:lvl1pPr algn="ctr" indent="0" marL="0">
+              <a:buNone/>
+              <a:defRPr lang="en-US" sz="800" dirty="0">
+                <a:solidFill>
+                  <a:srgbClr val="8A8A8A"/>
+                </a:solidFill>
+                <a:latin typeface="Arial" pitchFamily="34" charset="0"/>
+                <a:ea typeface="Arial" pitchFamily="34" charset="-122"/>
+                <a:cs typeface="Arial" pitchFamily="34" charset="-120"/>
+              </a:defRPr>
             </a:lvl1pPr>
           </a:lstStyle>
           <a:p>
-            <a:pPr indent="0" marL="0">
-              <a:buNone/>
-            </a:pPr>
-            <a:r>
-              <a:rPr lang="en-US" dirty="0">
-                <a:solidFill>
-                  <a:srgbClr val="000000"/>
-                </a:solidFill>
+            <a:pPr algn="ctr" indent="0" marL="0">
+              <a:buNone/>
+            </a:pPr>
+            <a:r>
+              <a:rPr lang="en-US" sz="800" dirty="0">
+                <a:solidFill>
+                  <a:srgbClr val="8A8A8A"/>
+                </a:solidFill>
+                <a:latin typeface="Arial" pitchFamily="34" charset="0"/>
+                <a:ea typeface="Arial" pitchFamily="34" charset="-122"/>
+                <a:cs typeface="Arial" pitchFamily="34" charset="-120"/>
               </a:rPr>
               <a:t>Photo 3</a:t>
             </a:r>
-            <a:endParaRPr lang="en-US" dirty="0"/>
+            <a:endParaRPr lang="en-US" sz="800" dirty="0"/>
           </a:p>
         </p:txBody>
       </p:sp>
@@ -1729,24 +1769,34 @@
         <p:txBody>
           <a:bodyPr wrap="square" rtlCol="0"/>
           <a:lstStyle>
-            <a:lvl1pPr indent="0" marL="0">
-              <a:buNone/>
-              <a:defRPr lang="en-US" dirty="0"/>
+            <a:lvl1pPr algn="ctr" indent="0" marL="0">
+              <a:buNone/>
+              <a:defRPr lang="en-US" sz="800" dirty="0">
+                <a:solidFill>
+                  <a:srgbClr val="8A8A8A"/>
+                </a:solidFill>
+                <a:latin typeface="Arial" pitchFamily="34" charset="0"/>
+                <a:ea typeface="Arial" pitchFamily="34" charset="-122"/>
+                <a:cs typeface="Arial" pitchFamily="34" charset="-120"/>
+              </a:defRPr>
             </a:lvl1pPr>
           </a:lstStyle>
           <a:p>
-            <a:pPr indent="0" marL="0">
-              <a:buNone/>
-            </a:pPr>
-            <a:r>
-              <a:rPr lang="en-US" dirty="0">
-                <a:solidFill>
-                  <a:srgbClr val="000000"/>
-                </a:solidFill>
+            <a:pPr algn="ctr" indent="0" marL="0">
+              <a:buNone/>
+            </a:pPr>
+            <a:r>
+              <a:rPr lang="en-US" sz="800" dirty="0">
+                <a:solidFill>
+                  <a:srgbClr val="8A8A8A"/>
+                </a:solidFill>
+                <a:latin typeface="Arial" pitchFamily="34" charset="0"/>
+                <a:ea typeface="Arial" pitchFamily="34" charset="-122"/>
+                <a:cs typeface="Arial" pitchFamily="34" charset="-120"/>
               </a:rPr>
               <a:t>Photo 4</a:t>
             </a:r>
-            <a:endParaRPr lang="en-US" dirty="0"/>
+            <a:endParaRPr lang="en-US" sz="800" dirty="0"/>
           </a:p>
         </p:txBody>
       </p:sp>
@@ -3148,15 +3198,15 @@
           <a:ln/>
         </p:spPr>
         <p:txBody>
-          <a:bodyPr wrap="square" rtlCol="0">
+          <a:bodyPr wrap="square" lIns="0" tIns="0" rIns="0" bIns="0" rtlCol="0" anchor="t">
             <a:normAutofit/>
           </a:bodyPr>
           <a:lstStyle/>
           <a:p>
-            <a:pPr indent="0" marL="0">
-              <a:buNone/>
-            </a:pPr>
-            <a:endParaRPr lang="en-US" dirty="0"/>
+            <a:pPr algn="ctr" indent="0" marL="0">
+              <a:buNone/>
+            </a:pPr>
+            <a:endParaRPr lang="en-US" sz="600" dirty="0"/>
           </a:p>
         </p:txBody>
       </p:sp>
@@ -3180,15 +3230,15 @@
           <a:ln/>
         </p:spPr>
         <p:txBody>
-          <a:bodyPr wrap="square" rtlCol="0">
+          <a:bodyPr wrap="square" lIns="0" tIns="0" rIns="0" bIns="0" rtlCol="0" anchor="t">
             <a:normAutofit/>
           </a:bodyPr>
           <a:lstStyle/>
           <a:p>
-            <a:pPr indent="0" marL="0">
-              <a:buNone/>
-            </a:pPr>
-            <a:endParaRPr lang="en-US" dirty="0"/>
+            <a:pPr algn="ctr" indent="0" marL="0">
+              <a:buNone/>
+            </a:pPr>
+            <a:endParaRPr lang="en-US" sz="800" dirty="0"/>
           </a:p>
         </p:txBody>
       </p:sp>
@@ -3212,15 +3262,15 @@
           <a:ln/>
         </p:spPr>
         <p:txBody>
-          <a:bodyPr wrap="square" rtlCol="0">
+          <a:bodyPr wrap="square" lIns="0" tIns="0" rIns="0" bIns="0" rtlCol="0" anchor="t">
             <a:normAutofit/>
           </a:bodyPr>
           <a:lstStyle/>
           <a:p>
-            <a:pPr indent="0" marL="0">
-              <a:buNone/>
-            </a:pPr>
-            <a:endParaRPr lang="en-US" dirty="0"/>
+            <a:pPr algn="ctr" indent="0" marL="0">
+              <a:buNone/>
+            </a:pPr>
+            <a:endParaRPr lang="en-US" sz="800" dirty="0"/>
           </a:p>
         </p:txBody>
       </p:sp>
@@ -3244,15 +3294,15 @@
           <a:ln/>
         </p:spPr>
         <p:txBody>
-          <a:bodyPr wrap="square" rtlCol="0">
+          <a:bodyPr wrap="square" lIns="0" tIns="0" rIns="0" bIns="0" rtlCol="0" anchor="t">
             <a:normAutofit/>
           </a:bodyPr>
           <a:lstStyle/>
           <a:p>
-            <a:pPr indent="0" marL="0">
-              <a:buNone/>
-            </a:pPr>
-            <a:endParaRPr lang="en-US" dirty="0"/>
+            <a:pPr algn="ctr" indent="0" marL="0">
+              <a:buNone/>
+            </a:pPr>
+            <a:endParaRPr lang="en-US" sz="800" dirty="0"/>
           </a:p>
         </p:txBody>
       </p:sp>
@@ -3276,15 +3326,15 @@
           <a:ln/>
         </p:spPr>
         <p:txBody>
-          <a:bodyPr wrap="square" rtlCol="0">
+          <a:bodyPr wrap="square" lIns="0" tIns="0" rIns="0" bIns="0" rtlCol="0" anchor="t">
             <a:normAutofit/>
           </a:bodyPr>
           <a:lstStyle/>
           <a:p>
-            <a:pPr indent="0" marL="0">
-              <a:buNone/>
-            </a:pPr>
-            <a:endParaRPr lang="en-US" dirty="0"/>
+            <a:pPr algn="ctr" indent="0" marL="0">
+              <a:buNone/>
+            </a:pPr>
+            <a:endParaRPr lang="en-US" sz="800" dirty="0"/>
           </a:p>
         </p:txBody>
       </p:sp>
@@ -4179,15 +4229,15 @@
           <a:ln/>
         </p:spPr>
         <p:txBody>
-          <a:bodyPr wrap="square" rtlCol="0">
+          <a:bodyPr wrap="square" lIns="0" tIns="0" rIns="0" bIns="0" rtlCol="0" anchor="t">
             <a:normAutofit/>
           </a:bodyPr>
           <a:lstStyle/>
           <a:p>
-            <a:pPr indent="0" marL="0">
-              <a:buNone/>
-            </a:pPr>
-            <a:endParaRPr lang="en-US" dirty="0"/>
+            <a:pPr algn="ctr" indent="0" marL="0">
+              <a:buNone/>
+            </a:pPr>
+            <a:endParaRPr lang="en-US" sz="600" dirty="0"/>
           </a:p>
         </p:txBody>
       </p:sp>
@@ -4211,15 +4261,15 @@
           <a:ln/>
         </p:spPr>
         <p:txBody>
-          <a:bodyPr wrap="square" rtlCol="0">
+          <a:bodyPr wrap="square" lIns="0" tIns="0" rIns="0" bIns="0" rtlCol="0" anchor="t">
             <a:normAutofit/>
           </a:bodyPr>
           <a:lstStyle/>
           <a:p>
-            <a:pPr indent="0" marL="0">
-              <a:buNone/>
-            </a:pPr>
-            <a:endParaRPr lang="en-US" dirty="0"/>
+            <a:pPr algn="ctr" indent="0" marL="0">
+              <a:buNone/>
+            </a:pPr>
+            <a:endParaRPr lang="en-US" sz="800" dirty="0"/>
           </a:p>
         </p:txBody>
       </p:sp>
@@ -4243,15 +4293,15 @@
           <a:ln/>
         </p:spPr>
         <p:txBody>
-          <a:bodyPr wrap="square" rtlCol="0">
+          <a:bodyPr wrap="square" lIns="0" tIns="0" rIns="0" bIns="0" rtlCol="0" anchor="t">
             <a:normAutofit/>
           </a:bodyPr>
           <a:lstStyle/>
           <a:p>
-            <a:pPr indent="0" marL="0">
-              <a:buNone/>
-            </a:pPr>
-            <a:endParaRPr lang="en-US" dirty="0"/>
+            <a:pPr algn="ctr" indent="0" marL="0">
+              <a:buNone/>
+            </a:pPr>
+            <a:endParaRPr lang="en-US" sz="800" dirty="0"/>
           </a:p>
         </p:txBody>
       </p:sp>
@@ -4275,15 +4325,15 @@
           <a:ln/>
         </p:spPr>
         <p:txBody>
-          <a:bodyPr wrap="square" rtlCol="0">
+          <a:bodyPr wrap="square" lIns="0" tIns="0" rIns="0" bIns="0" rtlCol="0" anchor="t">
             <a:normAutofit/>
           </a:bodyPr>
           <a:lstStyle/>
           <a:p>
-            <a:pPr indent="0" marL="0">
-              <a:buNone/>
-            </a:pPr>
-            <a:endParaRPr lang="en-US" dirty="0"/>
+            <a:pPr algn="ctr" indent="0" marL="0">
+              <a:buNone/>
+            </a:pPr>
+            <a:endParaRPr lang="en-US" sz="800" dirty="0"/>
           </a:p>
         </p:txBody>
       </p:sp>
@@ -4307,15 +4357,15 @@
           <a:ln/>
         </p:spPr>
         <p:txBody>
-          <a:bodyPr wrap="square" rtlCol="0">
+          <a:bodyPr wrap="square" lIns="0" tIns="0" rIns="0" bIns="0" rtlCol="0" anchor="t">
             <a:normAutofit/>
           </a:bodyPr>
           <a:lstStyle/>
           <a:p>
-            <a:pPr indent="0" marL="0">
-              <a:buNone/>
-            </a:pPr>
-            <a:endParaRPr lang="en-US" dirty="0"/>
+            <a:pPr algn="ctr" indent="0" marL="0">
+              <a:buNone/>
+            </a:pPr>
+            <a:endParaRPr lang="en-US" sz="800" dirty="0"/>
           </a:p>
         </p:txBody>
       </p:sp>

</xml_diff>